<commit_message>
refresh final deck with notebook figures and updated stats
- swap fig01/03/05/07 in pacman_rl_final.pptx for the PNGs rendered
  inline by monte_carlo_analysis.ipynb after the per-agent death-policy
  re-eval (n=50, seed=1000)
- update headline numbers in build_ppt.js (mean scores, hazard ratios,
  best run, TTF) to match the new summary_n50_seed1000.json
- check the regenerated notebooks/figures/ PNGs into the repo
</commit_message>
<xml_diff>
--- a/final_ppt/pacman_rl_final.pptx
+++ b/final_ppt/pacman_rl_final.pptx
@@ -2424,7 +2424,7 @@
                 <a:ea typeface="Arial" pitchFamily="34" charset="-122"/>
                 <a:cs typeface="Arial" pitchFamily="34" charset="-120"/>
               </a:rPr>
-              <a:t>• Replanning A* and Risk-Aware A* tie for top mean score (~2,200) and top clear rate (14% of seeds).</a:t>
+              <a:t>• Replanning A* and Risk-Aware A* tie for top mean score (~3,150) and top clear rate (14% of seeds).</a:t>
             </a:r>
             <a:endParaRPr lang="en-US" sz="1300" dirty="0"/>
           </a:p>
@@ -2441,7 +2441,7 @@
                 <a:ea typeface="Arial" pitchFamily="34" charset="-122"/>
                 <a:cs typeface="Arial" pitchFamily="34" charset="-120"/>
               </a:rPr>
-              <a:t>• Static A* (no replan) collapses to ~888 score and 24-step time-to-failure — replanning is the load-bearing trick.</a:t>
+              <a:t>• Static A* (no replan) reaches 1,479 mean score but dies at step 24 — replanning is the load-bearing trick.</a:t>
             </a:r>
             <a:endParaRPr lang="en-US" sz="1300" dirty="0"/>
           </a:p>
@@ -2458,7 +2458,7 @@
                 <a:ea typeface="Arial" pitchFamily="34" charset="-122"/>
                 <a:cs typeface="Arial" pitchFamily="34" charset="-120"/>
               </a:rPr>
-              <a:t>• Q-learning earns ~½ the score but ~6× lower hazard exposure — a fundamentally cautious learned policy.</a:t>
+              <a:t>• Q-learning earns ~½ the score but ~6–12× lower hazard exposure — a fundamentally cautious learned policy.</a:t>
             </a:r>
             <a:endParaRPr lang="en-US" sz="1300" dirty="0"/>
           </a:p>
@@ -5192,7 +5192,7 @@
                 <a:ea typeface="Arial" pitchFamily="34" charset="-122"/>
                 <a:cs typeface="Arial" pitchFamily="34" charset="-120"/>
               </a:rPr>
-              <a:t>• astar_replan and astar_risk_l* pile on top of each other near 2,200 — &gt;2× the next group.</a:t>
+              <a:t>• astar_replan (3181) and astar_risk_l* (≈3143) pile together — ~2× the next group.</a:t>
             </a:r>
             <a:endParaRPr lang="en-US" sz="1200" dirty="0"/>
           </a:p>
@@ -5209,7 +5209,7 @@
                 <a:ea typeface="Arial" pitchFamily="34" charset="-122"/>
                 <a:cs typeface="Arial" pitchFamily="34" charset="-120"/>
               </a:rPr>
-              <a:t>• qlearning_model1 (1089) narrowly beats the hand-coded heuristic (1080).</a:t>
+              <a:t>• Heuristic (1695) now leads the middle pack ahead of astar_static (1479) and qlearning_model1 (1439).</a:t>
             </a:r>
             <a:endParaRPr lang="en-US" sz="1200" dirty="0"/>
           </a:p>
@@ -5226,7 +5226,7 @@
                 <a:ea typeface="Arial" pitchFamily="34" charset="-122"/>
                 <a:cs typeface="Arial" pitchFamily="34" charset="-120"/>
               </a:rPr>
-              <a:t>• astar_static collapses to 888 — committing to a t=0 plan walks into ghosts.</a:t>
+              <a:t>• Q-learning models 2/3 sit lower (962, 656) — strong death penalty trades score for caution.</a:t>
             </a:r>
             <a:endParaRPr lang="en-US" sz="1200" dirty="0"/>
           </a:p>
@@ -5243,7 +5243,7 @@
                 <a:ea typeface="Arial" pitchFamily="34" charset="-122"/>
                 <a:cs typeface="Arial" pitchFamily="34" charset="-120"/>
               </a:rPr>
-              <a:t>• Random sanity floor: 111 ± 13.</a:t>
+              <a:t>• Random sanity floor: 167 ± 31.</a:t>
             </a:r>
             <a:endParaRPr lang="en-US" sz="1200" dirty="0"/>
           </a:p>
@@ -5311,7 +5311,7 @@
                 <a:ea typeface="Arial" pitchFamily="34" charset="-122"/>
                 <a:cs typeface="Arial" pitchFamily="34" charset="-120"/>
               </a:rPr>
-              <a:t>Take-away — the ×2.5 gap between static A* and the replanning family is the largest architectural delta in the project.</a:t>
+              <a:t>Take-away — the ~2× gap between static A* and the replanning family is the largest architectural delta in the project.</a:t>
             </a:r>
             <a:endParaRPr lang="en-US" sz="1300" dirty="0"/>
           </a:p>
@@ -5379,7 +5379,7 @@
                 <a:ea typeface="Arial" pitchFamily="34" charset="-122"/>
                 <a:cs typeface="Arial" pitchFamily="34" charset="-120"/>
               </a:rPr>
-              <a:t>Best single run: astar_replan / astar_risk = 7,590 (cleared the level on seeds 1004 and 1039).</a:t>
+              <a:t>Best single run: astar_replan / astar_risk = 7,800 (cleared the level on 14% of seeds in n=50).</a:t>
             </a:r>
             <a:endParaRPr lang="en-US" sz="1100" dirty="0"/>
           </a:p>
@@ -6576,7 +6576,7 @@
                 <a:ea typeface="Arial" pitchFamily="34" charset="-122"/>
                 <a:cs typeface="Arial" pitchFamily="34" charset="-120"/>
               </a:rPr>
-              <a:t>• Q-learners → upper-left, hazard ≈ 15–20.</a:t>
+              <a:t>• Q-learners → upper-left, hazard ≈ 9–19.</a:t>
             </a:r>
             <a:endParaRPr lang="en-US" sz="1150" dirty="0"/>
           </a:p>
@@ -6593,7 +6593,7 @@
                 <a:ea typeface="Arial" pitchFamily="34" charset="-122"/>
                 <a:cs typeface="Arial" pitchFamily="34" charset="-120"/>
               </a:rPr>
-              <a:t>• Planners (replan / risk-aware) → middle, hazard ≈ 110.</a:t>
+              <a:t>• Planners (replan / risk-aware) → middle, hazard ≈ 110, score ≈ 3,150.</a:t>
             </a:r>
             <a:endParaRPr lang="en-US" sz="1150" dirty="0"/>
           </a:p>
@@ -6610,7 +6610,7 @@
                 <a:ea typeface="Arial" pitchFamily="34" charset="-122"/>
                 <a:cs typeface="Arial" pitchFamily="34" charset="-120"/>
               </a:rPr>
-              <a:t>• Heuristic → far right, hazard ≈ 200.</a:t>
+              <a:t>• Heuristic → far right, hazard ≈ 201, score ≈ 1,695.</a:t>
             </a:r>
             <a:endParaRPr lang="en-US" sz="1150" dirty="0"/>
           </a:p>
@@ -6759,7 +6759,7 @@
                 <a:ea typeface="Arial" pitchFamily="34" charset="-122"/>
                 <a:cs typeface="Arial" pitchFamily="34" charset="-120"/>
               </a:rPr>
-              <a:t>• ~½ the score for ~6× less time within ghost-radius 2.</a:t>
+              <a:t>• ~½ the score for ~6–12× less time within ghost-radius 2.</a:t>
             </a:r>
             <a:endParaRPr lang="en-US" sz="1150" dirty="0"/>
           </a:p>
@@ -7234,7 +7234,7 @@
                 <a:ea typeface="Arial" pitchFamily="34" charset="-122"/>
                 <a:cs typeface="Arial" pitchFamily="34" charset="-120"/>
               </a:rPr>
-              <a:t>• Most score-greedy (1089 mean).</a:t>
+              <a:t>• Most score-greedy (1439 mean).</a:t>
             </a:r>
             <a:endParaRPr lang="en-US" sz="1100" dirty="0"/>
           </a:p>
@@ -7417,7 +7417,7 @@
                 <a:ea typeface="Arial" pitchFamily="34" charset="-122"/>
                 <a:cs typeface="Arial" pitchFamily="34" charset="-120"/>
               </a:rPr>
-              <a:t>• Used as the env death policy in the main eval for fair scoring.</a:t>
+              <a:t>• Heavily discourages dying without destabilising training.</a:t>
             </a:r>
             <a:endParaRPr lang="en-US" sz="1100" dirty="0"/>
           </a:p>
@@ -7434,7 +7434,7 @@
                 <a:ea typeface="Arial" pitchFamily="34" charset="-122"/>
                 <a:cs typeface="Arial" pitchFamily="34" charset="-120"/>
               </a:rPr>
-              <a:t>• Heavily discourages dying without destabilising training.</a:t>
+              <a:t>• Lowest hazard exposure of the three (~15).</a:t>
             </a:r>
             <a:endParaRPr lang="en-US" sz="1100" dirty="0"/>
           </a:p>
@@ -7566,7 +7566,7 @@
                 <a:ea typeface="Arial" pitchFamily="34" charset="-122"/>
                 <a:cs typeface="Arial" pitchFamily="34" charset="-120"/>
               </a:rPr>
-              <a:t>• Worst on every metric (569 mean, ≈54 step TTF).</a:t>
+              <a:t>• Lowest score (656 mean) but TTF ≈ 89 steps after extra training.</a:t>
             </a:r>
             <a:endParaRPr lang="en-US" sz="1100" dirty="0"/>
           </a:p>
@@ -7583,7 +7583,7 @@
                 <a:ea typeface="Arial" pitchFamily="34" charset="-122"/>
                 <a:cs typeface="Arial" pitchFamily="34" charset="-120"/>
               </a:rPr>
-              <a:t>• Highest variance — sometimes scores big, usually dies very early.</a:t>
+              <a:t>• Hazard ≈ 9 — the most cautious of the three.</a:t>
             </a:r>
             <a:endParaRPr lang="en-US" sz="1100" dirty="0"/>
           </a:p>
@@ -7600,7 +7600,7 @@
                 <a:ea typeface="Arial" pitchFamily="34" charset="-122"/>
                 <a:cs typeface="Arial" pitchFamily="34" charset="-120"/>
               </a:rPr>
-              <a:t>• Strong penalty + coarse state ⇒ unstable policy.</a:t>
+              <a:t>• Strong penalty teaches survival; score-greed has to be re-learned.</a:t>
             </a:r>
             <a:endParaRPr lang="en-US" sz="1100" dirty="0"/>
           </a:p>
@@ -7668,7 +7668,7 @@
                 <a:ea typeface="Arial" pitchFamily="34" charset="-122"/>
                 <a:cs typeface="Arial" pitchFamily="34" charset="-120"/>
               </a:rPr>
-              <a:t>Take-away — the death penalty is a tunable cautiousness knob, but the strongest version trains the most volatile policy.</a:t>
+              <a:t>Take-away — the death penalty is a tunable cautiousness knob: stronger penalty ⇒ less score, but lower hazard exposure.</a:t>
             </a:r>
             <a:endParaRPr lang="en-US" sz="1100" dirty="0"/>
           </a:p>
@@ -8217,7 +8217,7 @@
                 <a:ea typeface="Arial" pitchFamily="34" charset="-122"/>
                 <a:cs typeface="Arial" pitchFamily="34" charset="-120"/>
               </a:rPr>
-              <a:t>• Our run: planners ≈ 2,200 vs Q-learning 569–1,089 mean score.</a:t>
+              <a:t>• Our run: planners ≈ 3,150 vs Q-learning 656–1,439 mean score.</a:t>
             </a:r>
             <a:endParaRPr lang="en-US" sz="1150" dirty="0"/>
           </a:p>
@@ -8383,7 +8383,7 @@
                 <a:ea typeface="Arial" pitchFamily="34" charset="-122"/>
                 <a:cs typeface="Arial" pitchFamily="34" charset="-120"/>
               </a:rPr>
-              <a:t>• Our run: Q-learners earn less score but spend ~6× less time within ghost-radius 2.</a:t>
+              <a:t>• Our run: Q-learners earn less score but spend ~6–12× less time within ghost-radius 2.</a:t>
             </a:r>
             <a:endParaRPr lang="en-US" sz="1150" dirty="0"/>
           </a:p>
@@ -8851,7 +8851,7 @@
                 <a:ea typeface="Arial" pitchFamily="34" charset="-122"/>
                 <a:cs typeface="Arial" pitchFamily="34" charset="-120"/>
               </a:rPr>
-              <a:t>• 5× longer TTF and 2.5× higher score with no algorithmic change beyond "rerun every step".</a:t>
+              <a:t>• 5× longer TTF and ~2× higher score with no algorithmic change beyond "rerun every step".</a:t>
             </a:r>
             <a:endParaRPr lang="en-US" sz="1150" dirty="0"/>
           </a:p>
@@ -9132,7 +9132,7 @@
                 <a:ea typeface="Arial" pitchFamily="34" charset="-122"/>
                 <a:cs typeface="Arial" pitchFamily="34" charset="-120"/>
               </a:rPr>
-              <a:t>• ~6× less hazard exposure for ~2× less score vs replanning.</a:t>
+              <a:t>• ~6–12× less hazard exposure for ~½ the score vs replanning.</a:t>
             </a:r>
             <a:endParaRPr lang="en-US" sz="1150" dirty="0"/>
           </a:p>

</xml_diff>

<commit_message>
Manually added images to ppt
</commit_message>
<xml_diff>
--- a/final_ppt/pacman_rl_final.pptx
+++ b/final_ppt/pacman_rl_final.pptx
@@ -4,6 +4,9 @@
   <p:sldMasterIdLst>
     <p:sldMasterId id="2147483648" r:id="rId1"/>
   </p:sldMasterIdLst>
+  <p:notesMasterIdLst>
+    <p:notesMasterId r:id="rId11"/>
+  </p:notesMasterIdLst>
   <p:sldIdLst>
     <p:sldId id="256" r:id="rId2"/>
     <p:sldId id="257" r:id="rId3"/>
@@ -15,9 +18,6 @@
     <p:sldId id="263" r:id="rId9"/>
     <p:sldId id="264" r:id="rId10"/>
   </p:sldIdLst>
-  <p:notesMasterIdLst>
-    <p:notesMasterId r:id="rId11"/>
-  </p:notesMasterIdLst>
   <p:sldSz cx="12192000" cy="6858000"/>
   <p:notesSz cx="6858000" cy="12192000"/>
   <p:defaultTextStyle>
@@ -112,6 +112,11 @@
       </a:defRPr>
     </a:lvl9pPr>
   </p:defaultTextStyle>
+  <p:extLst>
+    <p:ext uri="{EFAFB233-063F-42B5-8137-9DF3F51BA10A}">
+      <p15:sldGuideLst xmlns:p15="http://schemas.microsoft.com/office/powerpoint/2012/main"/>
+    </p:ext>
+  </p:extLst>
 </p:presentation>
 </file>
 
@@ -137,234 +142,10 @@
           <a:chExt cx="0" cy="0"/>
         </a:xfrm>
       </p:grpSpPr>
-      <p:sp>
-        <p:nvSpPr>
-          <p:cNvPr id="2" name="Header Placeholder 1"/>
-          <p:cNvSpPr>
-            <a:spLocks noGrp="1"/>
-          </p:cNvSpPr>
-          <p:nvPr>
-            <p:ph type="hdr" sz="quarter"/>
-          </p:nvPr>
-        </p:nvSpPr>
-        <p:spPr>
-          <a:xfrm>
-            <a:off x="0" y="0"/>
-            <a:ext cx="2971800" cy="458788"/>
-          </a:xfrm>
-          <a:prstGeom prst="rect">
-            <a:avLst/>
-          </a:prstGeom>
-        </p:spPr>
-        <p:txBody>
-          <a:bodyPr vert="horz" lIns="91440" tIns="45720" rIns="91440" bIns="45720" rtlCol="0"/>
-          <a:lstStyle>
-            <a:lvl1pPr algn="l">
-              <a:defRPr sz="1200"/>
-            </a:lvl1pPr>
-          </a:lstStyle>
-          <a:p>
-            <a:endParaRPr lang="en-US"/>
-          </a:p>
-        </p:txBody>
-      </p:sp>
-      <p:sp>
-        <p:nvSpPr>
-          <p:cNvPr id="3" name="Date Placeholder 2"/>
-          <p:cNvSpPr>
-            <a:spLocks noGrp="1"/>
-          </p:cNvSpPr>
-          <p:nvPr>
-            <p:ph type="dt" idx="1"/>
-          </p:nvPr>
-        </p:nvSpPr>
-        <p:spPr>
-          <a:xfrm>
-            <a:off x="3884613" y="0"/>
-            <a:ext cx="2971800" cy="458788"/>
-          </a:xfrm>
-          <a:prstGeom prst="rect">
-            <a:avLst/>
-          </a:prstGeom>
-        </p:spPr>
-        <p:txBody>
-          <a:bodyPr vert="horz" lIns="91440" tIns="45720" rIns="91440" bIns="45720" rtlCol="0"/>
-          <a:lstStyle>
-            <a:lvl1pPr algn="r">
-              <a:defRPr sz="1200"/>
-            </a:lvl1pPr>
-          </a:lstStyle>
-          <a:p>
-            <a:fld id="{5282F153-3F37-0F45-9E97-73ACFA13230C}" type="datetimeFigureOut">
-              <a:rPr lang="en-US"/>
-              <a:t>7/23/19</a:t>
-            </a:fld>
-            <a:endParaRPr lang="en-US"/>
-          </a:p>
-        </p:txBody>
-      </p:sp>
-      <p:sp>
-        <p:nvSpPr>
-          <p:cNvPr id="4" name="Slide Image Placeholder 3"/>
-          <p:cNvSpPr>
-            <a:spLocks noGrp="1" noRot="1" noChangeAspect="1"/>
-          </p:cNvSpPr>
-          <p:nvPr>
-            <p:ph type="sldImg" idx="2"/>
-          </p:nvPr>
-        </p:nvSpPr>
-        <p:spPr>
-          <a:xfrm>
-            <a:off x="685800" y="1143000"/>
-            <a:ext cx="5486400" cy="3086100"/>
-          </a:xfrm>
-          <a:prstGeom prst="rect">
-            <a:avLst/>
-          </a:prstGeom>
-          <a:noFill/>
-          <a:ln w="12700">
-            <a:solidFill>
-              <a:prstClr val="black"/>
-            </a:solidFill>
-          </a:ln>
-        </p:spPr>
-        <p:txBody>
-          <a:bodyPr vert="horz" lIns="91440" tIns="45720" rIns="91440" bIns="45720" rtlCol="0" anchor="ctr"/>
-          <a:lstStyle/>
-          <a:p>
-            <a:endParaRPr lang="en-US"/>
-          </a:p>
-        </p:txBody>
-      </p:sp>
-      <p:sp>
-        <p:nvSpPr>
-          <p:cNvPr id="5" name="Notes Placeholder 4"/>
-          <p:cNvSpPr>
-            <a:spLocks noGrp="1"/>
-          </p:cNvSpPr>
-          <p:nvPr>
-            <p:ph type="body" sz="quarter" idx="3"/>
-          </p:nvPr>
-        </p:nvSpPr>
-        <p:spPr>
-          <a:xfrm>
-            <a:off x="685800" y="4400550"/>
-            <a:ext cx="5486400" cy="3600450"/>
-          </a:xfrm>
-          <a:prstGeom prst="rect">
-            <a:avLst/>
-          </a:prstGeom>
-        </p:spPr>
-        <p:txBody>
-          <a:bodyPr vert="horz" lIns="91440" tIns="45720" rIns="91440" bIns="45720" rtlCol="0"/>
-          <a:lstStyle/>
-          <a:p>
-            <a:pPr lvl="0"/>
-            <a:r>
-              <a:rPr lang="en-US"/>
-              <a:t>Click to edit Master text styles</a:t>
-            </a:r>
-          </a:p>
-          <a:p>
-            <a:pPr lvl="1"/>
-            <a:r>
-              <a:rPr lang="en-US"/>
-              <a:t>Second level</a:t>
-            </a:r>
-          </a:p>
-          <a:p>
-            <a:pPr lvl="2"/>
-            <a:r>
-              <a:rPr lang="en-US"/>
-              <a:t>Third level</a:t>
-            </a:r>
-          </a:p>
-          <a:p>
-            <a:pPr lvl="3"/>
-            <a:r>
-              <a:rPr lang="en-US"/>
-              <a:t>Fourth level</a:t>
-            </a:r>
-          </a:p>
-          <a:p>
-            <a:pPr lvl="4"/>
-            <a:r>
-              <a:rPr lang="en-US"/>
-              <a:t>Fifth level</a:t>
-            </a:r>
-          </a:p>
-        </p:txBody>
-      </p:sp>
-      <p:sp>
-        <p:nvSpPr>
-          <p:cNvPr id="6" name="Footer Placeholder 5"/>
-          <p:cNvSpPr>
-            <a:spLocks noGrp="1"/>
-          </p:cNvSpPr>
-          <p:nvPr>
-            <p:ph type="ftr" sz="quarter" idx="4"/>
-          </p:nvPr>
-        </p:nvSpPr>
-        <p:spPr>
-          <a:xfrm>
-            <a:off x="0" y="8685213"/>
-            <a:ext cx="2971800" cy="458787"/>
-          </a:xfrm>
-          <a:prstGeom prst="rect">
-            <a:avLst/>
-          </a:prstGeom>
-        </p:spPr>
-        <p:txBody>
-          <a:bodyPr vert="horz" lIns="91440" tIns="45720" rIns="91440" bIns="45720" rtlCol="0" anchor="b"/>
-          <a:lstStyle>
-            <a:lvl1pPr algn="l">
-              <a:defRPr sz="1200"/>
-            </a:lvl1pPr>
-          </a:lstStyle>
-          <a:p>
-            <a:endParaRPr lang="en-US"/>
-          </a:p>
-        </p:txBody>
-      </p:sp>
-      <p:sp>
-        <p:nvSpPr>
-          <p:cNvPr id="7" name="Slide Number Placeholder 6"/>
-          <p:cNvSpPr>
-            <a:spLocks noGrp="1"/>
-          </p:cNvSpPr>
-          <p:nvPr>
-            <p:ph type="sldNum" sz="quarter" idx="5"/>
-          </p:nvPr>
-        </p:nvSpPr>
-        <p:spPr>
-          <a:xfrm>
-            <a:off x="3884613" y="8685213"/>
-            <a:ext cx="2971800" cy="458787"/>
-          </a:xfrm>
-          <a:prstGeom prst="rect">
-            <a:avLst/>
-          </a:prstGeom>
-        </p:spPr>
-        <p:txBody>
-          <a:bodyPr vert="horz" lIns="91440" tIns="45720" rIns="91440" bIns="45720" rtlCol="0" anchor="b"/>
-          <a:lstStyle>
-            <a:lvl1pPr algn="r">
-              <a:defRPr sz="1200"/>
-            </a:lvl1pPr>
-          </a:lstStyle>
-          <a:p>
-            <a:fld id="{CE5E9CC1-C706-0F49-92D6-E571CC5EEA8F}" type="slidenum">
-              <a:rPr lang="en-US"/>
-              <a:t>‹#›</a:t>
-            </a:fld>
-            <a:endParaRPr lang="en-US"/>
-          </a:p>
-        </p:txBody>
-      </p:sp>
     </p:spTree>
     <p:extLst>
       <p:ext uri="{BB962C8B-B14F-4D97-AF65-F5344CB8AC3E}">
-        <p14:creationId xmlns:p14="http://schemas.microsoft.com/office/powerpoint/2010/main" val="1024086991"/>
+        <p14:creationId xmlns:p14="http://schemas.microsoft.com/office/powerpoint/2010/main" val="3517143498"/>
       </p:ext>
     </p:extLst>
   </p:cSld>
@@ -508,10 +289,6 @@
           <a:bodyPr/>
           <a:lstStyle/>
           <a:p>
-            <a:r>
-              <a:rPr lang="en-US" dirty="0"/>
-              <a:t/>
-            </a:r>
             <a:endParaRPr lang="en-US" dirty="0"/>
           </a:p>
         </p:txBody>
@@ -596,10 +373,6 @@
           <a:bodyPr/>
           <a:lstStyle/>
           <a:p>
-            <a:r>
-              <a:rPr lang="en-US" dirty="0"/>
-              <a:t/>
-            </a:r>
             <a:endParaRPr lang="en-US" dirty="0"/>
           </a:p>
         </p:txBody>
@@ -684,10 +457,6 @@
           <a:bodyPr/>
           <a:lstStyle/>
           <a:p>
-            <a:r>
-              <a:rPr lang="en-US" dirty="0"/>
-              <a:t/>
-            </a:r>
             <a:endParaRPr lang="en-US" dirty="0"/>
           </a:p>
         </p:txBody>
@@ -772,10 +541,6 @@
           <a:bodyPr/>
           <a:lstStyle/>
           <a:p>
-            <a:r>
-              <a:rPr lang="en-US" dirty="0"/>
-              <a:t/>
-            </a:r>
             <a:endParaRPr lang="en-US" dirty="0"/>
           </a:p>
         </p:txBody>
@@ -860,10 +625,6 @@
           <a:bodyPr/>
           <a:lstStyle/>
           <a:p>
-            <a:r>
-              <a:rPr lang="en-US" dirty="0"/>
-              <a:t/>
-            </a:r>
             <a:endParaRPr lang="en-US" dirty="0"/>
           </a:p>
         </p:txBody>
@@ -948,10 +709,6 @@
           <a:bodyPr/>
           <a:lstStyle/>
           <a:p>
-            <a:r>
-              <a:rPr lang="en-US" dirty="0"/>
-              <a:t/>
-            </a:r>
             <a:endParaRPr lang="en-US" dirty="0"/>
           </a:p>
         </p:txBody>
@@ -1036,10 +793,6 @@
           <a:bodyPr/>
           <a:lstStyle/>
           <a:p>
-            <a:r>
-              <a:rPr lang="en-US" dirty="0"/>
-              <a:t/>
-            </a:r>
             <a:endParaRPr lang="en-US" dirty="0"/>
           </a:p>
         </p:txBody>
@@ -1124,10 +877,6 @@
           <a:bodyPr/>
           <a:lstStyle/>
           <a:p>
-            <a:r>
-              <a:rPr lang="en-US" dirty="0"/>
-              <a:t/>
-            </a:r>
             <a:endParaRPr lang="en-US" dirty="0"/>
           </a:p>
         </p:txBody>
@@ -1212,10 +961,6 @@
           <a:bodyPr/>
           <a:lstStyle/>
           <a:p>
-            <a:r>
-              <a:rPr lang="en-US" dirty="0"/>
-              <a:t/>
-            </a:r>
             <a:endParaRPr lang="en-US" dirty="0"/>
           </a:p>
         </p:txBody>
@@ -1289,6 +1034,11 @@
 <file path=ppt/slideMasters/slideMaster1.xml><?xml version="1.0" encoding="utf-8"?>
 <p:sldMaster xmlns:a="http://schemas.openxmlformats.org/drawingml/2006/main" xmlns:r="http://schemas.openxmlformats.org/officeDocument/2006/relationships" xmlns:p="http://schemas.openxmlformats.org/presentationml/2006/main">
   <p:cSld>
+    <p:bg>
+      <p:bgRef idx="1001">
+        <a:schemeClr val="bg1"/>
+      </p:bgRef>
+    </p:bg>
     <p:spTree>
       <p:nvGrpSpPr>
         <p:cNvPr id="1" name=""/>
@@ -1571,6 +1321,7 @@
         <a:solidFill>
           <a:srgbClr val="FFFFFF"/>
         </a:solidFill>
+        <a:effectLst/>
       </p:bgPr>
     </p:bg>
     <p:spTree>
@@ -1589,14 +1340,14 @@
       </p:grpSpPr>
       <p:pic>
         <p:nvPicPr>
-          <p:cNvPr id="2" name="Image 0" descr="/Users/michael.liu/Documents/School/CS520/cs520-project/final_ppt/images/pacman_neon_bg.png">    </p:cNvPr>
+          <p:cNvPr id="2" name="Image 0" descr="/Users/michael.liu/Documents/School/CS520/cs520-project/final_ppt/images/pacman_neon_bg.png"/>
           <p:cNvPicPr>
             <a:picLocks noChangeAspect="1"/>
           </p:cNvPicPr>
           <p:nvPr/>
         </p:nvPicPr>
         <p:blipFill>
-          <a:blip r:embed="rId1"/>
+          <a:blip r:embed="rId3"/>
           <a:stretch>
             <a:fillRect/>
           </a:stretch>
@@ -1639,6 +1390,13 @@
             <a:prstDash val="solid"/>
           </a:ln>
         </p:spPr>
+        <p:txBody>
+          <a:bodyPr/>
+          <a:lstStyle/>
+          <a:p>
+            <a:endParaRPr lang="en-US"/>
+          </a:p>
+        </p:txBody>
       </p:sp>
       <p:sp>
         <p:nvSpPr>
@@ -1661,7 +1419,7 @@
           <a:bodyPr wrap="square" lIns="0" tIns="0" rIns="0" bIns="0" rtlCol="0" anchor="ctr"/>
           <a:lstStyle/>
           <a:p>
-            <a:pPr indent="0" marL="0">
+            <a:pPr marL="0" indent="0">
               <a:buNone/>
             </a:pPr>
             <a:r>
@@ -1703,6 +1461,13 @@
             <a:prstDash val="solid"/>
           </a:ln>
         </p:spPr>
+        <p:txBody>
+          <a:bodyPr/>
+          <a:lstStyle/>
+          <a:p>
+            <a:endParaRPr lang="en-US"/>
+          </a:p>
+        </p:txBody>
       </p:sp>
       <p:sp>
         <p:nvSpPr>
@@ -1732,6 +1497,13 @@
             <a:prstDash val="solid"/>
           </a:ln>
         </p:spPr>
+        <p:txBody>
+          <a:bodyPr/>
+          <a:lstStyle/>
+          <a:p>
+            <a:endParaRPr lang="en-US"/>
+          </a:p>
+        </p:txBody>
       </p:sp>
       <p:sp>
         <p:nvSpPr>
@@ -1754,7 +1526,7 @@
           <a:bodyPr wrap="square" lIns="0" tIns="0" rIns="0" bIns="0" rtlCol="0" anchor="ctr"/>
           <a:lstStyle/>
           <a:p>
-            <a:pPr indent="0" marL="0">
+            <a:pPr marL="0" indent="0">
               <a:buNone/>
             </a:pPr>
             <a:r>
@@ -1793,7 +1565,7 @@
           <a:bodyPr wrap="square" lIns="0" tIns="0" rIns="0" bIns="0" rtlCol="0" anchor="ctr"/>
           <a:lstStyle/>
           <a:p>
-            <a:pPr indent="0" marL="0">
+            <a:pPr marL="0" indent="0">
               <a:buNone/>
             </a:pPr>
             <a:r>
@@ -1839,6 +1611,13 @@
             <a:prstDash val="solid"/>
           </a:ln>
         </p:spPr>
+        <p:txBody>
+          <a:bodyPr/>
+          <a:lstStyle/>
+          <a:p>
+            <a:endParaRPr lang="en-US"/>
+          </a:p>
+        </p:txBody>
       </p:sp>
       <p:sp>
         <p:nvSpPr>
@@ -1861,7 +1640,7 @@
           <a:bodyPr wrap="square" lIns="0" tIns="0" rIns="0" bIns="0" rtlCol="0" anchor="ctr"/>
           <a:lstStyle/>
           <a:p>
-            <a:pPr algn="ctr" indent="0" marL="0">
+            <a:pPr marL="0" indent="0" algn="ctr">
               <a:buNone/>
             </a:pPr>
             <a:r>
@@ -1900,7 +1679,7 @@
           <a:bodyPr wrap="square" lIns="0" tIns="0" rIns="0" bIns="0" rtlCol="0" anchor="ctr"/>
           <a:lstStyle/>
           <a:p>
-            <a:pPr algn="ctr" indent="0" marL="0">
+            <a:pPr marL="0" indent="0" algn="ctr">
               <a:buNone/>
             </a:pPr>
             <a:r>
@@ -1946,6 +1725,13 @@
             <a:prstDash val="solid"/>
           </a:ln>
         </p:spPr>
+        <p:txBody>
+          <a:bodyPr/>
+          <a:lstStyle/>
+          <a:p>
+            <a:endParaRPr lang="en-US"/>
+          </a:p>
+        </p:txBody>
       </p:sp>
       <p:sp>
         <p:nvSpPr>
@@ -1968,7 +1754,7 @@
           <a:bodyPr wrap="square" lIns="0" tIns="0" rIns="0" bIns="0" rtlCol="0" anchor="ctr"/>
           <a:lstStyle/>
           <a:p>
-            <a:pPr algn="ctr" indent="0" marL="0">
+            <a:pPr marL="0" indent="0" algn="ctr">
               <a:buNone/>
             </a:pPr>
             <a:r>
@@ -2007,7 +1793,7 @@
           <a:bodyPr wrap="square" lIns="0" tIns="0" rIns="0" bIns="0" rtlCol="0" anchor="ctr"/>
           <a:lstStyle/>
           <a:p>
-            <a:pPr algn="ctr" indent="0" marL="0">
+            <a:pPr marL="0" indent="0" algn="ctr">
               <a:buNone/>
             </a:pPr>
             <a:r>
@@ -2053,6 +1839,13 @@
             <a:prstDash val="solid"/>
           </a:ln>
         </p:spPr>
+        <p:txBody>
+          <a:bodyPr/>
+          <a:lstStyle/>
+          <a:p>
+            <a:endParaRPr lang="en-US"/>
+          </a:p>
+        </p:txBody>
       </p:sp>
       <p:sp>
         <p:nvSpPr>
@@ -2075,7 +1868,7 @@
           <a:bodyPr wrap="square" lIns="0" tIns="0" rIns="0" bIns="0" rtlCol="0" anchor="ctr"/>
           <a:lstStyle/>
           <a:p>
-            <a:pPr algn="ctr" indent="0" marL="0">
+            <a:pPr marL="0" indent="0" algn="ctr">
               <a:buNone/>
             </a:pPr>
             <a:r>
@@ -2114,7 +1907,7 @@
           <a:bodyPr wrap="square" lIns="0" tIns="0" rIns="0" bIns="0" rtlCol="0" anchor="ctr"/>
           <a:lstStyle/>
           <a:p>
-            <a:pPr algn="ctr" indent="0" marL="0">
+            <a:pPr marL="0" indent="0" algn="ctr">
               <a:buNone/>
             </a:pPr>
             <a:r>
@@ -2160,6 +1953,13 @@
             <a:prstDash val="solid"/>
           </a:ln>
         </p:spPr>
+        <p:txBody>
+          <a:bodyPr/>
+          <a:lstStyle/>
+          <a:p>
+            <a:endParaRPr lang="en-US"/>
+          </a:p>
+        </p:txBody>
       </p:sp>
       <p:sp>
         <p:nvSpPr>
@@ -2182,7 +1982,7 @@
           <a:bodyPr wrap="square" lIns="0" tIns="0" rIns="0" bIns="0" rtlCol="0" anchor="ctr"/>
           <a:lstStyle/>
           <a:p>
-            <a:pPr indent="0" marL="0">
+            <a:pPr marL="0" indent="0">
               <a:buNone/>
             </a:pPr>
             <a:r>
@@ -2224,6 +2024,13 @@
             <a:prstDash val="solid"/>
           </a:ln>
         </p:spPr>
+        <p:txBody>
+          <a:bodyPr/>
+          <a:lstStyle/>
+          <a:p>
+            <a:endParaRPr lang="en-US"/>
+          </a:p>
+        </p:txBody>
       </p:sp>
       <p:sp>
         <p:nvSpPr>
@@ -2246,7 +2053,7 @@
           <a:bodyPr wrap="square" lIns="0" tIns="0" rIns="0" bIns="0" rtlCol="0" anchor="t"/>
           <a:lstStyle/>
           <a:p>
-            <a:pPr indent="0" marL="0">
+            <a:pPr marL="0" indent="0">
               <a:buNone/>
             </a:pPr>
             <a:r>
@@ -2263,7 +2070,7 @@
             <a:endParaRPr lang="en-US" sz="1400" dirty="0"/>
           </a:p>
           <a:p>
-            <a:pPr indent="0" marL="0">
+            <a:pPr marL="0" indent="0">
               <a:buNone/>
             </a:pPr>
             <a:r>
@@ -2280,7 +2087,7 @@
             <a:endParaRPr lang="en-US" sz="1400" dirty="0"/>
           </a:p>
           <a:p>
-            <a:pPr indent="0" marL="0">
+            <a:pPr marL="0" indent="0">
               <a:buNone/>
             </a:pPr>
             <a:r>
@@ -2297,7 +2104,7 @@
             <a:endParaRPr lang="en-US" sz="1400" dirty="0"/>
           </a:p>
           <a:p>
-            <a:pPr indent="0" marL="0">
+            <a:pPr marL="0" indent="0">
               <a:buNone/>
             </a:pPr>
             <a:r>
@@ -2314,7 +2121,7 @@
             <a:endParaRPr lang="en-US" sz="1400" dirty="0"/>
           </a:p>
           <a:p>
-            <a:pPr indent="0" marL="0">
+            <a:pPr marL="0" indent="0">
               <a:buNone/>
             </a:pPr>
             <a:r>
@@ -2360,6 +2167,13 @@
             <a:prstDash val="solid"/>
           </a:ln>
         </p:spPr>
+        <p:txBody>
+          <a:bodyPr/>
+          <a:lstStyle/>
+          <a:p>
+            <a:endParaRPr lang="en-US"/>
+          </a:p>
+        </p:txBody>
       </p:sp>
       <p:sp>
         <p:nvSpPr>
@@ -2382,7 +2196,7 @@
           <a:bodyPr wrap="square" lIns="0" tIns="0" rIns="0" bIns="0" rtlCol="0" anchor="ctr"/>
           <a:lstStyle/>
           <a:p>
-            <a:pPr indent="0" marL="0">
+            <a:pPr marL="0" indent="0">
               <a:buNone/>
             </a:pPr>
             <a:r>
@@ -2416,6 +2230,7 @@
         <a:solidFill>
           <a:srgbClr val="FFFFFF"/>
         </a:solidFill>
+        <a:effectLst/>
       </p:bgPr>
     </p:bg>
     <p:spTree>
@@ -2434,14 +2249,14 @@
       </p:grpSpPr>
       <p:pic>
         <p:nvPicPr>
-          <p:cNvPr id="2" name="Image 0" descr="/Users/michael.liu/Documents/School/CS520/cs520-project/final_ppt/images/pacman_neon_bg.png">    </p:cNvPr>
+          <p:cNvPr id="2" name="Image 0" descr="/Users/michael.liu/Documents/School/CS520/cs520-project/final_ppt/images/pacman_neon_bg.png"/>
           <p:cNvPicPr>
             <a:picLocks noChangeAspect="1"/>
           </p:cNvPicPr>
           <p:nvPr/>
         </p:nvPicPr>
         <p:blipFill>
-          <a:blip r:embed="rId1"/>
+          <a:blip r:embed="rId3"/>
           <a:stretch>
             <a:fillRect/>
           </a:stretch>
@@ -2484,6 +2299,13 @@
             <a:prstDash val="solid"/>
           </a:ln>
         </p:spPr>
+        <p:txBody>
+          <a:bodyPr/>
+          <a:lstStyle/>
+          <a:p>
+            <a:endParaRPr lang="en-US"/>
+          </a:p>
+        </p:txBody>
       </p:sp>
       <p:sp>
         <p:nvSpPr>
@@ -2506,7 +2328,7 @@
           <a:bodyPr wrap="square" lIns="0" tIns="0" rIns="0" bIns="0" rtlCol="0" anchor="ctr"/>
           <a:lstStyle/>
           <a:p>
-            <a:pPr indent="0" marL="0">
+            <a:pPr marL="0" indent="0">
               <a:buNone/>
             </a:pPr>
             <a:r>
@@ -2548,6 +2370,13 @@
             <a:prstDash val="solid"/>
           </a:ln>
         </p:spPr>
+        <p:txBody>
+          <a:bodyPr/>
+          <a:lstStyle/>
+          <a:p>
+            <a:endParaRPr lang="en-US"/>
+          </a:p>
+        </p:txBody>
       </p:sp>
       <p:sp>
         <p:nvSpPr>
@@ -2577,6 +2406,13 @@
             <a:prstDash val="solid"/>
           </a:ln>
         </p:spPr>
+        <p:txBody>
+          <a:bodyPr/>
+          <a:lstStyle/>
+          <a:p>
+            <a:endParaRPr lang="en-US"/>
+          </a:p>
+        </p:txBody>
       </p:sp>
       <p:sp>
         <p:nvSpPr>
@@ -2599,7 +2435,7 @@
           <a:bodyPr wrap="square" lIns="0" tIns="0" rIns="0" bIns="0" rtlCol="0" anchor="ctr"/>
           <a:lstStyle/>
           <a:p>
-            <a:pPr indent="0" marL="0">
+            <a:pPr marL="0" indent="0">
               <a:buNone/>
             </a:pPr>
             <a:r>
@@ -2645,6 +2481,13 @@
             <a:prstDash val="solid"/>
           </a:ln>
         </p:spPr>
+        <p:txBody>
+          <a:bodyPr/>
+          <a:lstStyle/>
+          <a:p>
+            <a:endParaRPr lang="en-US"/>
+          </a:p>
+        </p:txBody>
       </p:sp>
       <p:sp>
         <p:nvSpPr>
@@ -2667,7 +2510,7 @@
           <a:bodyPr wrap="square" lIns="0" tIns="0" rIns="0" bIns="0" rtlCol="0" anchor="ctr"/>
           <a:lstStyle/>
           <a:p>
-            <a:pPr algn="ctr" indent="0" marL="0">
+            <a:pPr marL="0" indent="0" algn="ctr">
               <a:buNone/>
             </a:pPr>
             <a:r>
@@ -2706,7 +2549,7 @@
           <a:bodyPr wrap="square" lIns="0" tIns="0" rIns="0" bIns="0" rtlCol="0" anchor="ctr"/>
           <a:lstStyle/>
           <a:p>
-            <a:pPr algn="ctr" indent="0" marL="0">
+            <a:pPr marL="0" indent="0" algn="ctr">
               <a:buNone/>
             </a:pPr>
             <a:r>
@@ -2752,6 +2595,13 @@
             <a:prstDash val="solid"/>
           </a:ln>
         </p:spPr>
+        <p:txBody>
+          <a:bodyPr/>
+          <a:lstStyle/>
+          <a:p>
+            <a:endParaRPr lang="en-US"/>
+          </a:p>
+        </p:txBody>
       </p:sp>
       <p:sp>
         <p:nvSpPr>
@@ -2774,7 +2624,7 @@
           <a:bodyPr wrap="square" lIns="0" tIns="0" rIns="0" bIns="0" rtlCol="0" anchor="ctr"/>
           <a:lstStyle/>
           <a:p>
-            <a:pPr algn="ctr" indent="0" marL="0">
+            <a:pPr marL="0" indent="0" algn="ctr">
               <a:buNone/>
             </a:pPr>
             <a:r>
@@ -2813,7 +2663,7 @@
           <a:bodyPr wrap="square" lIns="0" tIns="0" rIns="0" bIns="0" rtlCol="0" anchor="ctr"/>
           <a:lstStyle/>
           <a:p>
-            <a:pPr algn="ctr" indent="0" marL="0">
+            <a:pPr marL="0" indent="0" algn="ctr">
               <a:buNone/>
             </a:pPr>
             <a:r>
@@ -2859,6 +2709,13 @@
             <a:prstDash val="solid"/>
           </a:ln>
         </p:spPr>
+        <p:txBody>
+          <a:bodyPr/>
+          <a:lstStyle/>
+          <a:p>
+            <a:endParaRPr lang="en-US"/>
+          </a:p>
+        </p:txBody>
       </p:sp>
       <p:sp>
         <p:nvSpPr>
@@ -2881,7 +2738,7 @@
           <a:bodyPr wrap="square" lIns="0" tIns="0" rIns="0" bIns="0" rtlCol="0" anchor="ctr"/>
           <a:lstStyle/>
           <a:p>
-            <a:pPr algn="ctr" indent="0" marL="0">
+            <a:pPr marL="0" indent="0" algn="ctr">
               <a:buNone/>
             </a:pPr>
             <a:r>
@@ -2920,7 +2777,7 @@
           <a:bodyPr wrap="square" lIns="0" tIns="0" rIns="0" bIns="0" rtlCol="0" anchor="ctr"/>
           <a:lstStyle/>
           <a:p>
-            <a:pPr algn="ctr" indent="0" marL="0">
+            <a:pPr marL="0" indent="0" algn="ctr">
               <a:buNone/>
             </a:pPr>
             <a:r>
@@ -2966,6 +2823,13 @@
             <a:prstDash val="solid"/>
           </a:ln>
         </p:spPr>
+        <p:txBody>
+          <a:bodyPr/>
+          <a:lstStyle/>
+          <a:p>
+            <a:endParaRPr lang="en-US"/>
+          </a:p>
+        </p:txBody>
       </p:sp>
       <p:sp>
         <p:nvSpPr>
@@ -2988,7 +2852,7 @@
           <a:bodyPr wrap="square" lIns="0" tIns="0" rIns="0" bIns="0" rtlCol="0" anchor="ctr"/>
           <a:lstStyle/>
           <a:p>
-            <a:pPr algn="ctr" indent="0" marL="0">
+            <a:pPr marL="0" indent="0" algn="ctr">
               <a:buNone/>
             </a:pPr>
             <a:r>
@@ -3027,7 +2891,7 @@
           <a:bodyPr wrap="square" lIns="0" tIns="0" rIns="0" bIns="0" rtlCol="0" anchor="ctr"/>
           <a:lstStyle/>
           <a:p>
-            <a:pPr algn="ctr" indent="0" marL="0">
+            <a:pPr marL="0" indent="0" algn="ctr">
               <a:buNone/>
             </a:pPr>
             <a:r>
@@ -3073,6 +2937,13 @@
             <a:prstDash val="solid"/>
           </a:ln>
         </p:spPr>
+        <p:txBody>
+          <a:bodyPr/>
+          <a:lstStyle/>
+          <a:p>
+            <a:endParaRPr lang="en-US"/>
+          </a:p>
+        </p:txBody>
       </p:sp>
       <p:sp>
         <p:nvSpPr>
@@ -3095,7 +2966,7 @@
           <a:bodyPr wrap="square" lIns="0" tIns="0" rIns="0" bIns="0" rtlCol="0" anchor="ctr"/>
           <a:lstStyle/>
           <a:p>
-            <a:pPr algn="ctr" indent="0" marL="0">
+            <a:pPr marL="0" indent="0" algn="ctr">
               <a:buNone/>
             </a:pPr>
             <a:r>
@@ -3134,7 +3005,7 @@
           <a:bodyPr wrap="square" lIns="0" tIns="0" rIns="0" bIns="0" rtlCol="0" anchor="ctr"/>
           <a:lstStyle/>
           <a:p>
-            <a:pPr algn="ctr" indent="0" marL="0">
+            <a:pPr marL="0" indent="0" algn="ctr">
               <a:buNone/>
             </a:pPr>
             <a:r>
@@ -3180,6 +3051,13 @@
             <a:prstDash val="solid"/>
           </a:ln>
         </p:spPr>
+        <p:txBody>
+          <a:bodyPr/>
+          <a:lstStyle/>
+          <a:p>
+            <a:endParaRPr lang="en-US"/>
+          </a:p>
+        </p:txBody>
       </p:sp>
       <p:sp>
         <p:nvSpPr>
@@ -3202,7 +3080,7 @@
           <a:bodyPr wrap="square" lIns="0" tIns="0" rIns="0" bIns="0" rtlCol="0" anchor="ctr"/>
           <a:lstStyle/>
           <a:p>
-            <a:pPr algn="ctr" indent="0" marL="0">
+            <a:pPr marL="0" indent="0" algn="ctr">
               <a:buNone/>
             </a:pPr>
             <a:r>
@@ -3241,7 +3119,7 @@
           <a:bodyPr wrap="square" lIns="0" tIns="0" rIns="0" bIns="0" rtlCol="0" anchor="ctr"/>
           <a:lstStyle/>
           <a:p>
-            <a:pPr algn="ctr" indent="0" marL="0">
+            <a:pPr marL="0" indent="0" algn="ctr">
               <a:buNone/>
             </a:pPr>
             <a:r>
@@ -3287,6 +3165,13 @@
             <a:prstDash val="solid"/>
           </a:ln>
         </p:spPr>
+        <p:txBody>
+          <a:bodyPr/>
+          <a:lstStyle/>
+          <a:p>
+            <a:endParaRPr lang="en-US"/>
+          </a:p>
+        </p:txBody>
       </p:sp>
       <p:sp>
         <p:nvSpPr>
@@ -3309,7 +3194,7 @@
           <a:bodyPr wrap="square" lIns="0" tIns="0" rIns="0" bIns="0" rtlCol="0" anchor="ctr"/>
           <a:lstStyle/>
           <a:p>
-            <a:pPr indent="0" marL="0">
+            <a:pPr marL="0" indent="0">
               <a:buNone/>
             </a:pPr>
             <a:r>
@@ -3351,6 +3236,13 @@
             <a:prstDash val="solid"/>
           </a:ln>
         </p:spPr>
+        <p:txBody>
+          <a:bodyPr/>
+          <a:lstStyle/>
+          <a:p>
+            <a:endParaRPr lang="en-US"/>
+          </a:p>
+        </p:txBody>
       </p:sp>
       <p:sp>
         <p:nvSpPr>
@@ -3373,7 +3265,7 @@
           <a:bodyPr wrap="square" lIns="0" tIns="0" rIns="0" bIns="0" rtlCol="0" anchor="t"/>
           <a:lstStyle/>
           <a:p>
-            <a:pPr indent="0" marL="0">
+            <a:pPr marL="0" indent="0">
               <a:buNone/>
             </a:pPr>
             <a:r>
@@ -3390,7 +3282,7 @@
             <a:endParaRPr lang="en-US" sz="1200" dirty="0"/>
           </a:p>
           <a:p>
-            <a:pPr indent="0" marL="0">
+            <a:pPr marL="0" indent="0">
               <a:buNone/>
             </a:pPr>
             <a:r>
@@ -3407,7 +3299,7 @@
             <a:endParaRPr lang="en-US" sz="1200" dirty="0"/>
           </a:p>
           <a:p>
-            <a:pPr indent="0" marL="0">
+            <a:pPr marL="0" indent="0">
               <a:buNone/>
             </a:pPr>
             <a:r>
@@ -3424,7 +3316,7 @@
             <a:endParaRPr lang="en-US" sz="1200" dirty="0"/>
           </a:p>
           <a:p>
-            <a:pPr indent="0" marL="0">
+            <a:pPr marL="0" indent="0">
               <a:buNone/>
             </a:pPr>
             <a:r>
@@ -3441,7 +3333,7 @@
             <a:endParaRPr lang="en-US" sz="1200" dirty="0"/>
           </a:p>
           <a:p>
-            <a:pPr indent="0" marL="0">
+            <a:pPr marL="0" indent="0">
               <a:buNone/>
             </a:pPr>
             <a:r>
@@ -3487,6 +3379,13 @@
             <a:prstDash val="solid"/>
           </a:ln>
         </p:spPr>
+        <p:txBody>
+          <a:bodyPr/>
+          <a:lstStyle/>
+          <a:p>
+            <a:endParaRPr lang="en-US"/>
+          </a:p>
+        </p:txBody>
       </p:sp>
       <p:sp>
         <p:nvSpPr>
@@ -3509,7 +3408,7 @@
           <a:bodyPr wrap="square" lIns="0" tIns="0" rIns="0" bIns="0" rtlCol="0" anchor="ctr"/>
           <a:lstStyle/>
           <a:p>
-            <a:pPr indent="0" marL="0">
+            <a:pPr marL="0" indent="0">
               <a:buNone/>
             </a:pPr>
             <a:r>
@@ -3551,6 +3450,13 @@
             <a:prstDash val="solid"/>
           </a:ln>
         </p:spPr>
+        <p:txBody>
+          <a:bodyPr/>
+          <a:lstStyle/>
+          <a:p>
+            <a:endParaRPr lang="en-US"/>
+          </a:p>
+        </p:txBody>
       </p:sp>
       <p:sp>
         <p:nvSpPr>
@@ -3573,7 +3479,7 @@
           <a:bodyPr wrap="square" lIns="0" tIns="0" rIns="0" bIns="0" rtlCol="0" anchor="t"/>
           <a:lstStyle/>
           <a:p>
-            <a:pPr indent="0" marL="0">
+            <a:pPr marL="0" indent="0">
               <a:buNone/>
             </a:pPr>
             <a:r>
@@ -3590,7 +3496,7 @@
             <a:endParaRPr lang="en-US" sz="1200" dirty="0"/>
           </a:p>
           <a:p>
-            <a:pPr indent="0" marL="0">
+            <a:pPr marL="0" indent="0">
               <a:buNone/>
             </a:pPr>
             <a:r>
@@ -3607,7 +3513,7 @@
             <a:endParaRPr lang="en-US" sz="1200" dirty="0"/>
           </a:p>
           <a:p>
-            <a:pPr indent="0" marL="0">
+            <a:pPr marL="0" indent="0">
               <a:buNone/>
             </a:pPr>
             <a:r>
@@ -3624,7 +3530,7 @@
             <a:endParaRPr lang="en-US" sz="1200" dirty="0"/>
           </a:p>
           <a:p>
-            <a:pPr indent="0" marL="0">
+            <a:pPr marL="0" indent="0">
               <a:buNone/>
             </a:pPr>
             <a:r>
@@ -3641,7 +3547,7 @@
             <a:endParaRPr lang="en-US" sz="1200" dirty="0"/>
           </a:p>
           <a:p>
-            <a:pPr indent="0" marL="0">
+            <a:pPr marL="0" indent="0">
               <a:buNone/>
             </a:pPr>
             <a:r>
@@ -3687,6 +3593,13 @@
             <a:prstDash val="solid"/>
           </a:ln>
         </p:spPr>
+        <p:txBody>
+          <a:bodyPr/>
+          <a:lstStyle/>
+          <a:p>
+            <a:endParaRPr lang="en-US"/>
+          </a:p>
+        </p:txBody>
       </p:sp>
       <p:sp>
         <p:nvSpPr>
@@ -3709,7 +3622,7 @@
           <a:bodyPr wrap="square" lIns="0" tIns="0" rIns="0" bIns="0" rtlCol="0" anchor="ctr"/>
           <a:lstStyle/>
           <a:p>
-            <a:pPr indent="0" marL="0">
+            <a:pPr marL="0" indent="0">
               <a:buNone/>
             </a:pPr>
             <a:r>
@@ -3743,6 +3656,7 @@
         <a:solidFill>
           <a:srgbClr val="FFFFFF"/>
         </a:solidFill>
+        <a:effectLst/>
       </p:bgPr>
     </p:bg>
     <p:spTree>
@@ -3761,14 +3675,14 @@
       </p:grpSpPr>
       <p:pic>
         <p:nvPicPr>
-          <p:cNvPr id="2" name="Image 0" descr="/Users/michael.liu/Documents/School/CS520/cs520-project/final_ppt/images/pacman_neon_bg.png">    </p:cNvPr>
+          <p:cNvPr id="2" name="Image 0" descr="/Users/michael.liu/Documents/School/CS520/cs520-project/final_ppt/images/pacman_neon_bg.png"/>
           <p:cNvPicPr>
             <a:picLocks noChangeAspect="1"/>
           </p:cNvPicPr>
           <p:nvPr/>
         </p:nvPicPr>
         <p:blipFill>
-          <a:blip r:embed="rId1"/>
+          <a:blip r:embed="rId3"/>
           <a:stretch>
             <a:fillRect/>
           </a:stretch>
@@ -3811,6 +3725,13 @@
             <a:prstDash val="solid"/>
           </a:ln>
         </p:spPr>
+        <p:txBody>
+          <a:bodyPr/>
+          <a:lstStyle/>
+          <a:p>
+            <a:endParaRPr lang="en-US"/>
+          </a:p>
+        </p:txBody>
       </p:sp>
       <p:sp>
         <p:nvSpPr>
@@ -3833,7 +3754,7 @@
           <a:bodyPr wrap="square" lIns="0" tIns="0" rIns="0" bIns="0" rtlCol="0" anchor="ctr"/>
           <a:lstStyle/>
           <a:p>
-            <a:pPr indent="0" marL="0">
+            <a:pPr marL="0" indent="0">
               <a:buNone/>
             </a:pPr>
             <a:r>
@@ -3875,6 +3796,13 @@
             <a:prstDash val="solid"/>
           </a:ln>
         </p:spPr>
+        <p:txBody>
+          <a:bodyPr/>
+          <a:lstStyle/>
+          <a:p>
+            <a:endParaRPr lang="en-US"/>
+          </a:p>
+        </p:txBody>
       </p:sp>
       <p:sp>
         <p:nvSpPr>
@@ -3904,6 +3832,13 @@
             <a:prstDash val="solid"/>
           </a:ln>
         </p:spPr>
+        <p:txBody>
+          <a:bodyPr/>
+          <a:lstStyle/>
+          <a:p>
+            <a:endParaRPr lang="en-US"/>
+          </a:p>
+        </p:txBody>
       </p:sp>
       <p:sp>
         <p:nvSpPr>
@@ -3926,7 +3861,7 @@
           <a:bodyPr wrap="square" lIns="0" tIns="0" rIns="0" bIns="0" rtlCol="0" anchor="ctr"/>
           <a:lstStyle/>
           <a:p>
-            <a:pPr indent="0" marL="0">
+            <a:pPr marL="0" indent="0">
               <a:buNone/>
             </a:pPr>
             <a:r>
@@ -3972,6 +3907,13 @@
             <a:prstDash val="solid"/>
           </a:ln>
         </p:spPr>
+        <p:txBody>
+          <a:bodyPr/>
+          <a:lstStyle/>
+          <a:p>
+            <a:endParaRPr lang="en-US"/>
+          </a:p>
+        </p:txBody>
       </p:sp>
       <p:sp>
         <p:nvSpPr>
@@ -3994,7 +3936,7 @@
           <a:bodyPr wrap="square" lIns="0" tIns="0" rIns="0" bIns="0" rtlCol="0" anchor="ctr"/>
           <a:lstStyle/>
           <a:p>
-            <a:pPr indent="0" marL="0">
+            <a:pPr marL="0" indent="0">
               <a:buNone/>
             </a:pPr>
             <a:r>
@@ -4036,6 +3978,13 @@
             <a:prstDash val="solid"/>
           </a:ln>
         </p:spPr>
+        <p:txBody>
+          <a:bodyPr/>
+          <a:lstStyle/>
+          <a:p>
+            <a:endParaRPr lang="en-US"/>
+          </a:p>
+        </p:txBody>
       </p:sp>
       <p:sp>
         <p:nvSpPr>
@@ -4058,7 +4007,7 @@
           <a:bodyPr wrap="square" lIns="0" tIns="0" rIns="0" bIns="0" rtlCol="0" anchor="t"/>
           <a:lstStyle/>
           <a:p>
-            <a:pPr indent="0" marL="0">
+            <a:pPr marL="0" indent="0">
               <a:buNone/>
             </a:pPr>
             <a:r>
@@ -4075,7 +4024,7 @@
             <a:endParaRPr lang="en-US" sz="1200" dirty="0"/>
           </a:p>
           <a:p>
-            <a:pPr indent="0" marL="0">
+            <a:pPr marL="0" indent="0">
               <a:buNone/>
             </a:pPr>
             <a:r>
@@ -4092,7 +4041,7 @@
             <a:endParaRPr lang="en-US" sz="1200" dirty="0"/>
           </a:p>
           <a:p>
-            <a:pPr indent="0" marL="0">
+            <a:pPr marL="0" indent="0">
               <a:buNone/>
             </a:pPr>
             <a:r>
@@ -4138,6 +4087,13 @@
             <a:prstDash val="solid"/>
           </a:ln>
         </p:spPr>
+        <p:txBody>
+          <a:bodyPr/>
+          <a:lstStyle/>
+          <a:p>
+            <a:endParaRPr lang="en-US"/>
+          </a:p>
+        </p:txBody>
       </p:sp>
       <p:sp>
         <p:nvSpPr>
@@ -4160,7 +4116,7 @@
           <a:bodyPr wrap="square" lIns="0" tIns="0" rIns="0" bIns="0" rtlCol="0" anchor="ctr"/>
           <a:lstStyle/>
           <a:p>
-            <a:pPr indent="0" marL="0">
+            <a:pPr marL="0" indent="0">
               <a:buNone/>
             </a:pPr>
             <a:r>
@@ -4202,6 +4158,13 @@
             <a:prstDash val="solid"/>
           </a:ln>
         </p:spPr>
+        <p:txBody>
+          <a:bodyPr/>
+          <a:lstStyle/>
+          <a:p>
+            <a:endParaRPr lang="en-US"/>
+          </a:p>
+        </p:txBody>
       </p:sp>
       <p:sp>
         <p:nvSpPr>
@@ -4224,7 +4187,7 @@
           <a:bodyPr wrap="square" lIns="0" tIns="0" rIns="0" bIns="0" rtlCol="0" anchor="t"/>
           <a:lstStyle/>
           <a:p>
-            <a:pPr indent="0" marL="0">
+            <a:pPr marL="0" indent="0">
               <a:buNone/>
             </a:pPr>
             <a:r>
@@ -4241,7 +4204,7 @@
             <a:endParaRPr lang="en-US" sz="1200" dirty="0"/>
           </a:p>
           <a:p>
-            <a:pPr indent="0" marL="0">
+            <a:pPr marL="0" indent="0">
               <a:buNone/>
             </a:pPr>
             <a:r>
@@ -4258,7 +4221,7 @@
             <a:endParaRPr lang="en-US" sz="1200" dirty="0"/>
           </a:p>
           <a:p>
-            <a:pPr indent="0" marL="0">
+            <a:pPr marL="0" indent="0">
               <a:buNone/>
             </a:pPr>
             <a:r>
@@ -4304,6 +4267,13 @@
             <a:prstDash val="solid"/>
           </a:ln>
         </p:spPr>
+        <p:txBody>
+          <a:bodyPr/>
+          <a:lstStyle/>
+          <a:p>
+            <a:endParaRPr lang="en-US"/>
+          </a:p>
+        </p:txBody>
       </p:sp>
       <p:sp>
         <p:nvSpPr>
@@ -4326,7 +4296,7 @@
           <a:bodyPr wrap="square" lIns="0" tIns="0" rIns="0" bIns="0" rtlCol="0" anchor="ctr"/>
           <a:lstStyle/>
           <a:p>
-            <a:pPr indent="0" marL="0">
+            <a:pPr marL="0" indent="0">
               <a:buNone/>
             </a:pPr>
             <a:r>
@@ -4368,6 +4338,13 @@
             <a:prstDash val="solid"/>
           </a:ln>
         </p:spPr>
+        <p:txBody>
+          <a:bodyPr/>
+          <a:lstStyle/>
+          <a:p>
+            <a:endParaRPr lang="en-US"/>
+          </a:p>
+        </p:txBody>
       </p:sp>
       <p:sp>
         <p:nvSpPr>
@@ -4390,7 +4367,7 @@
           <a:bodyPr wrap="square" lIns="0" tIns="0" rIns="0" bIns="0" rtlCol="0" anchor="t"/>
           <a:lstStyle/>
           <a:p>
-            <a:pPr indent="0" marL="0">
+            <a:pPr marL="0" indent="0">
               <a:buNone/>
             </a:pPr>
             <a:r>
@@ -4407,7 +4384,7 @@
             <a:endParaRPr lang="en-US" sz="1200" dirty="0"/>
           </a:p>
           <a:p>
-            <a:pPr indent="0" marL="0">
+            <a:pPr marL="0" indent="0">
               <a:buNone/>
             </a:pPr>
             <a:r>
@@ -4424,7 +4401,7 @@
             <a:endParaRPr lang="en-US" sz="1200" dirty="0"/>
           </a:p>
           <a:p>
-            <a:pPr indent="0" marL="0">
+            <a:pPr marL="0" indent="0">
               <a:buNone/>
             </a:pPr>
             <a:r>
@@ -4470,6 +4447,13 @@
             <a:prstDash val="solid"/>
           </a:ln>
         </p:spPr>
+        <p:txBody>
+          <a:bodyPr/>
+          <a:lstStyle/>
+          <a:p>
+            <a:endParaRPr lang="en-US"/>
+          </a:p>
+        </p:txBody>
       </p:sp>
       <p:sp>
         <p:nvSpPr>
@@ -4492,7 +4476,7 @@
           <a:bodyPr wrap="square" lIns="0" tIns="0" rIns="0" bIns="0" rtlCol="0" anchor="ctr"/>
           <a:lstStyle/>
           <a:p>
-            <a:pPr indent="0" marL="0">
+            <a:pPr marL="0" indent="0">
               <a:buNone/>
             </a:pPr>
             <a:r>
@@ -4534,6 +4518,13 @@
             <a:prstDash val="solid"/>
           </a:ln>
         </p:spPr>
+        <p:txBody>
+          <a:bodyPr/>
+          <a:lstStyle/>
+          <a:p>
+            <a:endParaRPr lang="en-US"/>
+          </a:p>
+        </p:txBody>
       </p:sp>
       <p:sp>
         <p:nvSpPr>
@@ -4556,7 +4547,7 @@
           <a:bodyPr wrap="square" lIns="0" tIns="0" rIns="0" bIns="0" rtlCol="0" anchor="t"/>
           <a:lstStyle/>
           <a:p>
-            <a:pPr indent="0" marL="0">
+            <a:pPr marL="0" indent="0">
               <a:buNone/>
             </a:pPr>
             <a:r>
@@ -4573,7 +4564,7 @@
             <a:endParaRPr lang="en-US" sz="1200" dirty="0"/>
           </a:p>
           <a:p>
-            <a:pPr indent="0" marL="0">
+            <a:pPr marL="0" indent="0">
               <a:buNone/>
             </a:pPr>
             <a:r>
@@ -4590,7 +4581,7 @@
             <a:endParaRPr lang="en-US" sz="1200" dirty="0"/>
           </a:p>
           <a:p>
-            <a:pPr indent="0" marL="0">
+            <a:pPr marL="0" indent="0">
               <a:buNone/>
             </a:pPr>
             <a:r>
@@ -4636,6 +4627,13 @@
             <a:prstDash val="solid"/>
           </a:ln>
         </p:spPr>
+        <p:txBody>
+          <a:bodyPr/>
+          <a:lstStyle/>
+          <a:p>
+            <a:endParaRPr lang="en-US"/>
+          </a:p>
+        </p:txBody>
       </p:sp>
       <p:sp>
         <p:nvSpPr>
@@ -4658,7 +4656,7 @@
           <a:bodyPr wrap="square" lIns="0" tIns="0" rIns="0" bIns="0" rtlCol="0" anchor="ctr"/>
           <a:lstStyle/>
           <a:p>
-            <a:pPr indent="0" marL="0">
+            <a:pPr marL="0" indent="0">
               <a:buNone/>
             </a:pPr>
             <a:r>
@@ -4692,6 +4690,7 @@
         <a:solidFill>
           <a:srgbClr val="FFFFFF"/>
         </a:solidFill>
+        <a:effectLst/>
       </p:bgPr>
     </p:bg>
     <p:spTree>
@@ -4710,14 +4709,14 @@
       </p:grpSpPr>
       <p:pic>
         <p:nvPicPr>
-          <p:cNvPr id="2" name="Image 0" descr="/Users/michael.liu/Documents/School/CS520/cs520-project/final_ppt/images/pacman_neon_bg.png">    </p:cNvPr>
+          <p:cNvPr id="2" name="Image 0" descr="/Users/michael.liu/Documents/School/CS520/cs520-project/final_ppt/images/pacman_neon_bg.png"/>
           <p:cNvPicPr>
             <a:picLocks noChangeAspect="1"/>
           </p:cNvPicPr>
           <p:nvPr/>
         </p:nvPicPr>
         <p:blipFill>
-          <a:blip r:embed="rId1"/>
+          <a:blip r:embed="rId3"/>
           <a:stretch>
             <a:fillRect/>
           </a:stretch>
@@ -4760,6 +4759,13 @@
             <a:prstDash val="solid"/>
           </a:ln>
         </p:spPr>
+        <p:txBody>
+          <a:bodyPr/>
+          <a:lstStyle/>
+          <a:p>
+            <a:endParaRPr lang="en-US"/>
+          </a:p>
+        </p:txBody>
       </p:sp>
       <p:sp>
         <p:nvSpPr>
@@ -4782,7 +4788,7 @@
           <a:bodyPr wrap="square" lIns="0" tIns="0" rIns="0" bIns="0" rtlCol="0" anchor="ctr"/>
           <a:lstStyle/>
           <a:p>
-            <a:pPr indent="0" marL="0">
+            <a:pPr marL="0" indent="0">
               <a:buNone/>
             </a:pPr>
             <a:r>
@@ -4824,6 +4830,13 @@
             <a:prstDash val="solid"/>
           </a:ln>
         </p:spPr>
+        <p:txBody>
+          <a:bodyPr/>
+          <a:lstStyle/>
+          <a:p>
+            <a:endParaRPr lang="en-US"/>
+          </a:p>
+        </p:txBody>
       </p:sp>
       <p:sp>
         <p:nvSpPr>
@@ -4853,17 +4866,24 @@
             <a:prstDash val="solid"/>
           </a:ln>
         </p:spPr>
+        <p:txBody>
+          <a:bodyPr/>
+          <a:lstStyle/>
+          <a:p>
+            <a:endParaRPr lang="en-US"/>
+          </a:p>
+        </p:txBody>
       </p:sp>
       <p:pic>
         <p:nvPicPr>
-          <p:cNvPr id="7" name="Image 1" descr="/Users/michael.liu/Documents/School/CS520/cs520-project/notebooks/figures/fig01_score_bars.png">    </p:cNvPr>
+          <p:cNvPr id="7" name="Image 1" descr="/Users/michael.liu/Documents/School/CS520/cs520-project/notebooks/figures/fig01_score_bars.png"/>
           <p:cNvPicPr>
             <a:picLocks noChangeAspect="1"/>
           </p:cNvPicPr>
           <p:nvPr/>
         </p:nvPicPr>
         <p:blipFill>
-          <a:blip r:embed="rId2"/>
+          <a:blip r:embed="rId4"/>
           <a:stretch>
             <a:fillRect/>
           </a:stretch>
@@ -4899,7 +4919,7 @@
           <a:bodyPr wrap="square" lIns="0" tIns="0" rIns="0" bIns="0" rtlCol="0" anchor="ctr"/>
           <a:lstStyle/>
           <a:p>
-            <a:pPr algn="ctr" indent="0" marL="0">
+            <a:pPr marL="0" indent="0" algn="ctr">
               <a:buNone/>
             </a:pPr>
             <a:r>
@@ -4945,6 +4965,13 @@
             <a:prstDash val="solid"/>
           </a:ln>
         </p:spPr>
+        <p:txBody>
+          <a:bodyPr/>
+          <a:lstStyle/>
+          <a:p>
+            <a:endParaRPr lang="en-US"/>
+          </a:p>
+        </p:txBody>
       </p:sp>
       <p:sp>
         <p:nvSpPr>
@@ -4967,7 +4994,7 @@
           <a:bodyPr wrap="square" lIns="0" tIns="0" rIns="0" bIns="0" rtlCol="0" anchor="ctr"/>
           <a:lstStyle/>
           <a:p>
-            <a:pPr indent="0" marL="0">
+            <a:pPr marL="0" indent="0">
               <a:buNone/>
             </a:pPr>
             <a:r>
@@ -5009,6 +5036,13 @@
             <a:prstDash val="solid"/>
           </a:ln>
         </p:spPr>
+        <p:txBody>
+          <a:bodyPr/>
+          <a:lstStyle/>
+          <a:p>
+            <a:endParaRPr lang="en-US"/>
+          </a:p>
+        </p:txBody>
       </p:sp>
       <p:sp>
         <p:nvSpPr>
@@ -5031,7 +5065,7 @@
           <a:bodyPr wrap="square" lIns="0" tIns="0" rIns="0" bIns="0" rtlCol="0" anchor="t"/>
           <a:lstStyle/>
           <a:p>
-            <a:pPr indent="0" marL="0">
+            <a:pPr marL="0" indent="0">
               <a:buNone/>
             </a:pPr>
             <a:r>
@@ -5048,7 +5082,7 @@
             <a:endParaRPr lang="en-US" sz="1200" dirty="0"/>
           </a:p>
           <a:p>
-            <a:pPr indent="0" marL="0">
+            <a:pPr marL="0" indent="0">
               <a:buNone/>
             </a:pPr>
             <a:r>
@@ -5065,7 +5099,7 @@
             <a:endParaRPr lang="en-US" sz="1200" dirty="0"/>
           </a:p>
           <a:p>
-            <a:pPr indent="0" marL="0">
+            <a:pPr marL="0" indent="0">
               <a:buNone/>
             </a:pPr>
             <a:r>
@@ -5082,7 +5116,7 @@
             <a:endParaRPr lang="en-US" sz="1200" dirty="0"/>
           </a:p>
           <a:p>
-            <a:pPr indent="0" marL="0">
+            <a:pPr marL="0" indent="0">
               <a:buNone/>
             </a:pPr>
             <a:r>
@@ -5128,6 +5162,13 @@
             <a:prstDash val="solid"/>
           </a:ln>
         </p:spPr>
+        <p:txBody>
+          <a:bodyPr/>
+          <a:lstStyle/>
+          <a:p>
+            <a:endParaRPr lang="en-US"/>
+          </a:p>
+        </p:txBody>
       </p:sp>
       <p:sp>
         <p:nvSpPr>
@@ -5150,7 +5191,7 @@
           <a:bodyPr wrap="square" lIns="0" tIns="0" rIns="0" bIns="0" rtlCol="0" anchor="ctr"/>
           <a:lstStyle/>
           <a:p>
-            <a:pPr indent="0" marL="0">
+            <a:pPr marL="0" indent="0">
               <a:buNone/>
             </a:pPr>
             <a:r>
@@ -5196,6 +5237,13 @@
             <a:prstDash val="solid"/>
           </a:ln>
         </p:spPr>
+        <p:txBody>
+          <a:bodyPr/>
+          <a:lstStyle/>
+          <a:p>
+            <a:endParaRPr lang="en-US"/>
+          </a:p>
+        </p:txBody>
       </p:sp>
       <p:sp>
         <p:nvSpPr>
@@ -5218,7 +5266,7 @@
           <a:bodyPr wrap="square" lIns="0" tIns="0" rIns="0" bIns="0" rtlCol="0" anchor="ctr"/>
           <a:lstStyle/>
           <a:p>
-            <a:pPr indent="0" marL="0">
+            <a:pPr marL="0" indent="0">
               <a:buNone/>
             </a:pPr>
             <a:r>
@@ -5252,6 +5300,7 @@
         <a:solidFill>
           <a:srgbClr val="FFFFFF"/>
         </a:solidFill>
+        <a:effectLst/>
       </p:bgPr>
     </p:bg>
     <p:spTree>
@@ -5270,14 +5319,14 @@
       </p:grpSpPr>
       <p:pic>
         <p:nvPicPr>
-          <p:cNvPr id="2" name="Image 0" descr="/Users/michael.liu/Documents/School/CS520/cs520-project/final_ppt/images/pacman_neon_bg.png">    </p:cNvPr>
+          <p:cNvPr id="2" name="Image 0" descr="/Users/michael.liu/Documents/School/CS520/cs520-project/final_ppt/images/pacman_neon_bg.png"/>
           <p:cNvPicPr>
             <a:picLocks noChangeAspect="1"/>
           </p:cNvPicPr>
           <p:nvPr/>
         </p:nvPicPr>
         <p:blipFill>
-          <a:blip r:embed="rId1"/>
+          <a:blip r:embed="rId3"/>
           <a:stretch>
             <a:fillRect/>
           </a:stretch>
@@ -5320,6 +5369,13 @@
             <a:prstDash val="solid"/>
           </a:ln>
         </p:spPr>
+        <p:txBody>
+          <a:bodyPr/>
+          <a:lstStyle/>
+          <a:p>
+            <a:endParaRPr lang="en-US"/>
+          </a:p>
+        </p:txBody>
       </p:sp>
       <p:sp>
         <p:nvSpPr>
@@ -5342,7 +5398,7 @@
           <a:bodyPr wrap="square" lIns="0" tIns="0" rIns="0" bIns="0" rtlCol="0" anchor="ctr"/>
           <a:lstStyle/>
           <a:p>
-            <a:pPr indent="0" marL="0">
+            <a:pPr marL="0" indent="0">
               <a:buNone/>
             </a:pPr>
             <a:r>
@@ -5384,6 +5440,13 @@
             <a:prstDash val="solid"/>
           </a:ln>
         </p:spPr>
+        <p:txBody>
+          <a:bodyPr/>
+          <a:lstStyle/>
+          <a:p>
+            <a:endParaRPr lang="en-US"/>
+          </a:p>
+        </p:txBody>
       </p:sp>
       <p:sp>
         <p:nvSpPr>
@@ -5413,17 +5476,24 @@
             <a:prstDash val="solid"/>
           </a:ln>
         </p:spPr>
+        <p:txBody>
+          <a:bodyPr/>
+          <a:lstStyle/>
+          <a:p>
+            <a:endParaRPr lang="en-US"/>
+          </a:p>
+        </p:txBody>
       </p:sp>
       <p:pic>
         <p:nvPicPr>
-          <p:cNvPr id="7" name="Image 1" descr="/Users/michael.liu/Documents/School/CS520/cs520-project/notebooks/figures/fig03_survival_panels.png">    </p:cNvPr>
+          <p:cNvPr id="7" name="Image 1" descr="/Users/michael.liu/Documents/School/CS520/cs520-project/notebooks/figures/fig03_survival_panels.png"/>
           <p:cNvPicPr>
             <a:picLocks noChangeAspect="1"/>
           </p:cNvPicPr>
           <p:nvPr/>
         </p:nvPicPr>
         <p:blipFill>
-          <a:blip r:embed="rId2"/>
+          <a:blip r:embed="rId4"/>
           <a:stretch>
             <a:fillRect/>
           </a:stretch>
@@ -5459,7 +5529,7 @@
           <a:bodyPr wrap="square" lIns="0" tIns="0" rIns="0" bIns="0" rtlCol="0" anchor="ctr"/>
           <a:lstStyle/>
           <a:p>
-            <a:pPr algn="ctr" indent="0" marL="0">
+            <a:pPr marL="0" indent="0" algn="ctr">
               <a:buNone/>
             </a:pPr>
             <a:r>
@@ -5505,6 +5575,13 @@
             <a:prstDash val="solid"/>
           </a:ln>
         </p:spPr>
+        <p:txBody>
+          <a:bodyPr/>
+          <a:lstStyle/>
+          <a:p>
+            <a:endParaRPr lang="en-US"/>
+          </a:p>
+        </p:txBody>
       </p:sp>
       <p:sp>
         <p:nvSpPr>
@@ -5527,7 +5604,7 @@
           <a:bodyPr wrap="square" lIns="0" tIns="0" rIns="0" bIns="0" rtlCol="0" anchor="ctr"/>
           <a:lstStyle/>
           <a:p>
-            <a:pPr indent="0" marL="0">
+            <a:pPr marL="0" indent="0">
               <a:buNone/>
             </a:pPr>
             <a:r>
@@ -5569,6 +5646,13 @@
             <a:prstDash val="solid"/>
           </a:ln>
         </p:spPr>
+        <p:txBody>
+          <a:bodyPr/>
+          <a:lstStyle/>
+          <a:p>
+            <a:endParaRPr lang="en-US"/>
+          </a:p>
+        </p:txBody>
       </p:sp>
       <p:sp>
         <p:nvSpPr>
@@ -5591,7 +5675,7 @@
           <a:bodyPr wrap="square" lIns="0" tIns="0" rIns="0" bIns="0" rtlCol="0" anchor="t"/>
           <a:lstStyle/>
           <a:p>
-            <a:pPr indent="0" marL="0">
+            <a:pPr marL="0" indent="0">
               <a:buNone/>
             </a:pPr>
             <a:r>
@@ -5608,7 +5692,7 @@
             <a:endParaRPr lang="en-US" sz="1100" dirty="0"/>
           </a:p>
           <a:p>
-            <a:pPr indent="0" marL="0">
+            <a:pPr marL="0" indent="0">
               <a:buNone/>
             </a:pPr>
             <a:r>
@@ -5625,7 +5709,7 @@
             <a:endParaRPr lang="en-US" sz="1100" dirty="0"/>
           </a:p>
           <a:p>
-            <a:pPr indent="0" marL="0">
+            <a:pPr marL="0" indent="0">
               <a:buNone/>
             </a:pPr>
             <a:r>
@@ -5671,6 +5755,13 @@
             <a:prstDash val="solid"/>
           </a:ln>
         </p:spPr>
+        <p:txBody>
+          <a:bodyPr/>
+          <a:lstStyle/>
+          <a:p>
+            <a:endParaRPr lang="en-US"/>
+          </a:p>
+        </p:txBody>
       </p:sp>
       <p:sp>
         <p:nvSpPr>
@@ -5693,7 +5784,7 @@
           <a:bodyPr wrap="square" lIns="0" tIns="0" rIns="0" bIns="0" rtlCol="0" anchor="ctr"/>
           <a:lstStyle/>
           <a:p>
-            <a:pPr indent="0" marL="0">
+            <a:pPr marL="0" indent="0">
               <a:buNone/>
             </a:pPr>
             <a:r>
@@ -5735,6 +5826,13 @@
             <a:prstDash val="solid"/>
           </a:ln>
         </p:spPr>
+        <p:txBody>
+          <a:bodyPr/>
+          <a:lstStyle/>
+          <a:p>
+            <a:endParaRPr lang="en-US"/>
+          </a:p>
+        </p:txBody>
       </p:sp>
       <p:sp>
         <p:nvSpPr>
@@ -5757,7 +5855,7 @@
           <a:bodyPr wrap="square" lIns="0" tIns="0" rIns="0" bIns="0" rtlCol="0" anchor="t"/>
           <a:lstStyle/>
           <a:p>
-            <a:pPr indent="0" marL="0">
+            <a:pPr marL="0" indent="0">
               <a:buNone/>
             </a:pPr>
             <a:r>
@@ -5774,7 +5872,7 @@
             <a:endParaRPr lang="en-US" sz="1100" dirty="0"/>
           </a:p>
           <a:p>
-            <a:pPr indent="0" marL="0">
+            <a:pPr marL="0" indent="0">
               <a:buNone/>
             </a:pPr>
             <a:r>
@@ -5791,7 +5889,7 @@
             <a:endParaRPr lang="en-US" sz="1100" dirty="0"/>
           </a:p>
           <a:p>
-            <a:pPr indent="0" marL="0">
+            <a:pPr marL="0" indent="0">
               <a:buNone/>
             </a:pPr>
             <a:r>
@@ -5837,6 +5935,13 @@
             <a:prstDash val="solid"/>
           </a:ln>
         </p:spPr>
+        <p:txBody>
+          <a:bodyPr/>
+          <a:lstStyle/>
+          <a:p>
+            <a:endParaRPr lang="en-US"/>
+          </a:p>
+        </p:txBody>
       </p:sp>
       <p:sp>
         <p:nvSpPr>
@@ -5859,7 +5964,7 @@
           <a:bodyPr wrap="square" lIns="0" tIns="0" rIns="0" bIns="0" rtlCol="0" anchor="ctr"/>
           <a:lstStyle/>
           <a:p>
-            <a:pPr indent="0" marL="0">
+            <a:pPr marL="0" indent="0">
               <a:buNone/>
             </a:pPr>
             <a:r>
@@ -5901,6 +6006,13 @@
             <a:prstDash val="solid"/>
           </a:ln>
         </p:spPr>
+        <p:txBody>
+          <a:bodyPr/>
+          <a:lstStyle/>
+          <a:p>
+            <a:endParaRPr lang="en-US"/>
+          </a:p>
+        </p:txBody>
       </p:sp>
       <p:sp>
         <p:nvSpPr>
@@ -5923,7 +6035,7 @@
           <a:bodyPr wrap="square" lIns="0" tIns="0" rIns="0" bIns="0" rtlCol="0" anchor="t"/>
           <a:lstStyle/>
           <a:p>
-            <a:pPr indent="0" marL="0">
+            <a:pPr marL="0" indent="0">
               <a:buNone/>
             </a:pPr>
             <a:r>
@@ -5940,7 +6052,7 @@
             <a:endParaRPr lang="en-US" sz="1100" dirty="0"/>
           </a:p>
           <a:p>
-            <a:pPr indent="0" marL="0">
+            <a:pPr marL="0" indent="0">
               <a:buNone/>
             </a:pPr>
             <a:r>
@@ -5957,7 +6069,7 @@
             <a:endParaRPr lang="en-US" sz="1100" dirty="0"/>
           </a:p>
           <a:p>
-            <a:pPr indent="0" marL="0">
+            <a:pPr marL="0" indent="0">
               <a:buNone/>
             </a:pPr>
             <a:r>
@@ -6003,6 +6115,13 @@
             <a:prstDash val="solid"/>
           </a:ln>
         </p:spPr>
+        <p:txBody>
+          <a:bodyPr/>
+          <a:lstStyle/>
+          <a:p>
+            <a:endParaRPr lang="en-US"/>
+          </a:p>
+        </p:txBody>
       </p:sp>
       <p:sp>
         <p:nvSpPr>
@@ -6025,7 +6144,7 @@
           <a:bodyPr wrap="square" lIns="0" tIns="0" rIns="0" bIns="0" rtlCol="0" anchor="ctr"/>
           <a:lstStyle/>
           <a:p>
-            <a:pPr indent="0" marL="0">
+            <a:pPr marL="0" indent="0">
               <a:buNone/>
             </a:pPr>
             <a:r>
@@ -6059,6 +6178,7 @@
         <a:solidFill>
           <a:srgbClr val="FFFFFF"/>
         </a:solidFill>
+        <a:effectLst/>
       </p:bgPr>
     </p:bg>
     <p:spTree>
@@ -6077,14 +6197,14 @@
       </p:grpSpPr>
       <p:pic>
         <p:nvPicPr>
-          <p:cNvPr id="2" name="Image 0" descr="/Users/michael.liu/Documents/School/CS520/cs520-project/final_ppt/images/pacman_neon_bg.png">    </p:cNvPr>
+          <p:cNvPr id="2" name="Image 0" descr="/Users/michael.liu/Documents/School/CS520/cs520-project/final_ppt/images/pacman_neon_bg.png"/>
           <p:cNvPicPr>
             <a:picLocks noChangeAspect="1"/>
           </p:cNvPicPr>
           <p:nvPr/>
         </p:nvPicPr>
         <p:blipFill>
-          <a:blip r:embed="rId1"/>
+          <a:blip r:embed="rId3"/>
           <a:stretch>
             <a:fillRect/>
           </a:stretch>
@@ -6127,6 +6247,13 @@
             <a:prstDash val="solid"/>
           </a:ln>
         </p:spPr>
+        <p:txBody>
+          <a:bodyPr/>
+          <a:lstStyle/>
+          <a:p>
+            <a:endParaRPr lang="en-US"/>
+          </a:p>
+        </p:txBody>
       </p:sp>
       <p:sp>
         <p:nvSpPr>
@@ -6149,7 +6276,7 @@
           <a:bodyPr wrap="square" lIns="0" tIns="0" rIns="0" bIns="0" rtlCol="0" anchor="ctr"/>
           <a:lstStyle/>
           <a:p>
-            <a:pPr indent="0" marL="0">
+            <a:pPr marL="0" indent="0">
               <a:buNone/>
             </a:pPr>
             <a:r>
@@ -6191,6 +6318,13 @@
             <a:prstDash val="solid"/>
           </a:ln>
         </p:spPr>
+        <p:txBody>
+          <a:bodyPr/>
+          <a:lstStyle/>
+          <a:p>
+            <a:endParaRPr lang="en-US"/>
+          </a:p>
+        </p:txBody>
       </p:sp>
       <p:sp>
         <p:nvSpPr>
@@ -6220,17 +6354,24 @@
             <a:prstDash val="solid"/>
           </a:ln>
         </p:spPr>
+        <p:txBody>
+          <a:bodyPr/>
+          <a:lstStyle/>
+          <a:p>
+            <a:endParaRPr lang="en-US"/>
+          </a:p>
+        </p:txBody>
       </p:sp>
       <p:pic>
         <p:nvPicPr>
-          <p:cNvPr id="7" name="Image 1" descr="/Users/michael.liu/Documents/School/CS520/cs520-project/notebooks/figures/fig05_risk_reward.png">    </p:cNvPr>
+          <p:cNvPr id="7" name="Image 1" descr="/Users/michael.liu/Documents/School/CS520/cs520-project/notebooks/figures/fig05_risk_reward.png"/>
           <p:cNvPicPr>
             <a:picLocks noChangeAspect="1"/>
           </p:cNvPicPr>
           <p:nvPr/>
         </p:nvPicPr>
         <p:blipFill>
-          <a:blip r:embed="rId2"/>
+          <a:blip r:embed="rId4"/>
           <a:stretch>
             <a:fillRect/>
           </a:stretch>
@@ -6266,7 +6407,7 @@
           <a:bodyPr wrap="square" lIns="0" tIns="0" rIns="0" bIns="0" rtlCol="0" anchor="ctr"/>
           <a:lstStyle/>
           <a:p>
-            <a:pPr algn="ctr" indent="0" marL="0">
+            <a:pPr marL="0" indent="0" algn="ctr">
               <a:buNone/>
             </a:pPr>
             <a:r>
@@ -6312,6 +6453,13 @@
             <a:prstDash val="solid"/>
           </a:ln>
         </p:spPr>
+        <p:txBody>
+          <a:bodyPr/>
+          <a:lstStyle/>
+          <a:p>
+            <a:endParaRPr lang="en-US"/>
+          </a:p>
+        </p:txBody>
       </p:sp>
       <p:sp>
         <p:nvSpPr>
@@ -6334,7 +6482,7 @@
           <a:bodyPr wrap="square" lIns="0" tIns="0" rIns="0" bIns="0" rtlCol="0" anchor="ctr"/>
           <a:lstStyle/>
           <a:p>
-            <a:pPr indent="0" marL="0">
+            <a:pPr marL="0" indent="0">
               <a:buNone/>
             </a:pPr>
             <a:r>
@@ -6376,6 +6524,13 @@
             <a:prstDash val="solid"/>
           </a:ln>
         </p:spPr>
+        <p:txBody>
+          <a:bodyPr/>
+          <a:lstStyle/>
+          <a:p>
+            <a:endParaRPr lang="en-US"/>
+          </a:p>
+        </p:txBody>
       </p:sp>
       <p:sp>
         <p:nvSpPr>
@@ -6398,7 +6553,7 @@
           <a:bodyPr wrap="square" lIns="0" tIns="0" rIns="0" bIns="0" rtlCol="0" anchor="t"/>
           <a:lstStyle/>
           <a:p>
-            <a:pPr indent="0" marL="0">
+            <a:pPr marL="0" indent="0">
               <a:buNone/>
             </a:pPr>
             <a:r>
@@ -6415,7 +6570,7 @@
             <a:endParaRPr lang="en-US" sz="1150" dirty="0"/>
           </a:p>
           <a:p>
-            <a:pPr indent="0" marL="0">
+            <a:pPr marL="0" indent="0">
               <a:buNone/>
             </a:pPr>
             <a:r>
@@ -6432,7 +6587,7 @@
             <a:endParaRPr lang="en-US" sz="1150" dirty="0"/>
           </a:p>
           <a:p>
-            <a:pPr indent="0" marL="0">
+            <a:pPr marL="0" indent="0">
               <a:buNone/>
             </a:pPr>
             <a:r>
@@ -6478,6 +6633,13 @@
             <a:prstDash val="solid"/>
           </a:ln>
         </p:spPr>
+        <p:txBody>
+          <a:bodyPr/>
+          <a:lstStyle/>
+          <a:p>
+            <a:endParaRPr lang="en-US"/>
+          </a:p>
+        </p:txBody>
       </p:sp>
       <p:sp>
         <p:nvSpPr>
@@ -6500,7 +6662,7 @@
           <a:bodyPr wrap="square" lIns="0" tIns="0" rIns="0" bIns="0" rtlCol="0" anchor="ctr"/>
           <a:lstStyle/>
           <a:p>
-            <a:pPr indent="0" marL="0">
+            <a:pPr marL="0" indent="0">
               <a:buNone/>
             </a:pPr>
             <a:r>
@@ -6542,6 +6704,13 @@
             <a:prstDash val="solid"/>
           </a:ln>
         </p:spPr>
+        <p:txBody>
+          <a:bodyPr/>
+          <a:lstStyle/>
+          <a:p>
+            <a:endParaRPr lang="en-US"/>
+          </a:p>
+        </p:txBody>
       </p:sp>
       <p:sp>
         <p:nvSpPr>
@@ -6564,7 +6733,7 @@
           <a:bodyPr wrap="square" lIns="0" tIns="0" rIns="0" bIns="0" rtlCol="0" anchor="t"/>
           <a:lstStyle/>
           <a:p>
-            <a:pPr indent="0" marL="0">
+            <a:pPr marL="0" indent="0">
               <a:buNone/>
             </a:pPr>
             <a:r>
@@ -6581,7 +6750,7 @@
             <a:endParaRPr lang="en-US" sz="1150" dirty="0"/>
           </a:p>
           <a:p>
-            <a:pPr indent="0" marL="0">
+            <a:pPr marL="0" indent="0">
               <a:buNone/>
             </a:pPr>
             <a:r>
@@ -6598,7 +6767,7 @@
             <a:endParaRPr lang="en-US" sz="1150" dirty="0"/>
           </a:p>
           <a:p>
-            <a:pPr indent="0" marL="0">
+            <a:pPr marL="0" indent="0">
               <a:buNone/>
             </a:pPr>
             <a:r>
@@ -6615,7 +6784,7 @@
             <a:endParaRPr lang="en-US" sz="1150" dirty="0"/>
           </a:p>
           <a:p>
-            <a:pPr indent="0" marL="0">
+            <a:pPr marL="0" indent="0">
               <a:buNone/>
             </a:pPr>
             <a:r>
@@ -6661,6 +6830,13 @@
             <a:prstDash val="solid"/>
           </a:ln>
         </p:spPr>
+        <p:txBody>
+          <a:bodyPr/>
+          <a:lstStyle/>
+          <a:p>
+            <a:endParaRPr lang="en-US"/>
+          </a:p>
+        </p:txBody>
       </p:sp>
       <p:sp>
         <p:nvSpPr>
@@ -6683,7 +6859,7 @@
           <a:bodyPr wrap="square" lIns="0" tIns="0" rIns="0" bIns="0" rtlCol="0" anchor="ctr"/>
           <a:lstStyle/>
           <a:p>
-            <a:pPr indent="0" marL="0">
+            <a:pPr marL="0" indent="0">
               <a:buNone/>
             </a:pPr>
             <a:r>
@@ -6717,6 +6893,7 @@
         <a:solidFill>
           <a:srgbClr val="FFFFFF"/>
         </a:solidFill>
+        <a:effectLst/>
       </p:bgPr>
     </p:bg>
     <p:spTree>
@@ -6735,14 +6912,14 @@
       </p:grpSpPr>
       <p:pic>
         <p:nvPicPr>
-          <p:cNvPr id="2" name="Image 0" descr="/Users/michael.liu/Documents/School/CS520/cs520-project/final_ppt/images/pacman_neon_bg.png">    </p:cNvPr>
+          <p:cNvPr id="2" name="Image 0" descr="/Users/michael.liu/Documents/School/CS520/cs520-project/final_ppt/images/pacman_neon_bg.png"/>
           <p:cNvPicPr>
             <a:picLocks noChangeAspect="1"/>
           </p:cNvPicPr>
           <p:nvPr/>
         </p:nvPicPr>
         <p:blipFill>
-          <a:blip r:embed="rId1"/>
+          <a:blip r:embed="rId3"/>
           <a:stretch>
             <a:fillRect/>
           </a:stretch>
@@ -6785,6 +6962,13 @@
             <a:prstDash val="solid"/>
           </a:ln>
         </p:spPr>
+        <p:txBody>
+          <a:bodyPr/>
+          <a:lstStyle/>
+          <a:p>
+            <a:endParaRPr lang="en-US"/>
+          </a:p>
+        </p:txBody>
       </p:sp>
       <p:sp>
         <p:nvSpPr>
@@ -6807,7 +6991,7 @@
           <a:bodyPr wrap="square" lIns="0" tIns="0" rIns="0" bIns="0" rtlCol="0" anchor="ctr"/>
           <a:lstStyle/>
           <a:p>
-            <a:pPr indent="0" marL="0">
+            <a:pPr marL="0" indent="0">
               <a:buNone/>
             </a:pPr>
             <a:r>
@@ -6849,6 +7033,13 @@
             <a:prstDash val="solid"/>
           </a:ln>
         </p:spPr>
+        <p:txBody>
+          <a:bodyPr/>
+          <a:lstStyle/>
+          <a:p>
+            <a:endParaRPr lang="en-US"/>
+          </a:p>
+        </p:txBody>
       </p:sp>
       <p:sp>
         <p:nvSpPr>
@@ -6878,17 +7069,24 @@
             <a:prstDash val="solid"/>
           </a:ln>
         </p:spPr>
+        <p:txBody>
+          <a:bodyPr/>
+          <a:lstStyle/>
+          <a:p>
+            <a:endParaRPr lang="en-US"/>
+          </a:p>
+        </p:txBody>
       </p:sp>
       <p:pic>
         <p:nvPicPr>
-          <p:cNvPr id="7" name="Image 1" descr="/Users/michael.liu/Documents/School/CS520/cs520-project/notebooks/figures/fig07_qlearning_ablation.png">    </p:cNvPr>
+          <p:cNvPr id="7" name="Image 1" descr="/Users/michael.liu/Documents/School/CS520/cs520-project/notebooks/figures/fig07_qlearning_ablation.png"/>
           <p:cNvPicPr>
             <a:picLocks noChangeAspect="1"/>
           </p:cNvPicPr>
           <p:nvPr/>
         </p:nvPicPr>
         <p:blipFill>
-          <a:blip r:embed="rId2"/>
+          <a:blip r:embed="rId4"/>
           <a:stretch>
             <a:fillRect/>
           </a:stretch>
@@ -6924,7 +7122,7 @@
           <a:bodyPr wrap="square" lIns="0" tIns="0" rIns="0" bIns="0" rtlCol="0" anchor="ctr"/>
           <a:lstStyle/>
           <a:p>
-            <a:pPr algn="ctr" indent="0" marL="0">
+            <a:pPr marL="0" indent="0" algn="ctr">
               <a:buNone/>
             </a:pPr>
             <a:r>
@@ -6970,6 +7168,13 @@
             <a:prstDash val="solid"/>
           </a:ln>
         </p:spPr>
+        <p:txBody>
+          <a:bodyPr/>
+          <a:lstStyle/>
+          <a:p>
+            <a:endParaRPr lang="en-US"/>
+          </a:p>
+        </p:txBody>
       </p:sp>
       <p:sp>
         <p:nvSpPr>
@@ -6992,7 +7197,7 @@
           <a:bodyPr wrap="square" lIns="0" tIns="0" rIns="0" bIns="0" rtlCol="0" anchor="ctr"/>
           <a:lstStyle/>
           <a:p>
-            <a:pPr indent="0" marL="0">
+            <a:pPr marL="0" indent="0">
               <a:buNone/>
             </a:pPr>
             <a:r>
@@ -7034,6 +7239,13 @@
             <a:prstDash val="solid"/>
           </a:ln>
         </p:spPr>
+        <p:txBody>
+          <a:bodyPr/>
+          <a:lstStyle/>
+          <a:p>
+            <a:endParaRPr lang="en-US"/>
+          </a:p>
+        </p:txBody>
       </p:sp>
       <p:sp>
         <p:nvSpPr>
@@ -7056,7 +7268,7 @@
           <a:bodyPr wrap="square" lIns="0" tIns="0" rIns="0" bIns="0" rtlCol="0" anchor="t"/>
           <a:lstStyle/>
           <a:p>
-            <a:pPr indent="0" marL="0">
+            <a:pPr marL="0" indent="0">
               <a:buNone/>
             </a:pPr>
             <a:r>
@@ -7073,7 +7285,7 @@
             <a:endParaRPr lang="en-US" sz="1100" dirty="0"/>
           </a:p>
           <a:p>
-            <a:pPr indent="0" marL="0">
+            <a:pPr marL="0" indent="0">
               <a:buNone/>
             </a:pPr>
             <a:r>
@@ -7090,7 +7302,7 @@
             <a:endParaRPr lang="en-US" sz="1100" dirty="0"/>
           </a:p>
           <a:p>
-            <a:pPr indent="0" marL="0">
+            <a:pPr marL="0" indent="0">
               <a:buNone/>
             </a:pPr>
             <a:r>
@@ -7136,6 +7348,13 @@
             <a:prstDash val="solid"/>
           </a:ln>
         </p:spPr>
+        <p:txBody>
+          <a:bodyPr/>
+          <a:lstStyle/>
+          <a:p>
+            <a:endParaRPr lang="en-US"/>
+          </a:p>
+        </p:txBody>
       </p:sp>
       <p:sp>
         <p:nvSpPr>
@@ -7158,7 +7377,7 @@
           <a:bodyPr wrap="square" lIns="0" tIns="0" rIns="0" bIns="0" rtlCol="0" anchor="ctr"/>
           <a:lstStyle/>
           <a:p>
-            <a:pPr indent="0" marL="0">
+            <a:pPr marL="0" indent="0">
               <a:buNone/>
             </a:pPr>
             <a:r>
@@ -7200,6 +7419,13 @@
             <a:prstDash val="solid"/>
           </a:ln>
         </p:spPr>
+        <p:txBody>
+          <a:bodyPr/>
+          <a:lstStyle/>
+          <a:p>
+            <a:endParaRPr lang="en-US"/>
+          </a:p>
+        </p:txBody>
       </p:sp>
       <p:sp>
         <p:nvSpPr>
@@ -7222,7 +7448,7 @@
           <a:bodyPr wrap="square" lIns="0" tIns="0" rIns="0" bIns="0" rtlCol="0" anchor="t"/>
           <a:lstStyle/>
           <a:p>
-            <a:pPr indent="0" marL="0">
+            <a:pPr marL="0" indent="0">
               <a:buNone/>
             </a:pPr>
             <a:r>
@@ -7239,7 +7465,7 @@
             <a:endParaRPr lang="en-US" sz="1100" dirty="0"/>
           </a:p>
           <a:p>
-            <a:pPr indent="0" marL="0">
+            <a:pPr marL="0" indent="0">
               <a:buNone/>
             </a:pPr>
             <a:r>
@@ -7256,7 +7482,7 @@
             <a:endParaRPr lang="en-US" sz="1100" dirty="0"/>
           </a:p>
           <a:p>
-            <a:pPr indent="0" marL="0">
+            <a:pPr marL="0" indent="0">
               <a:buNone/>
             </a:pPr>
             <a:r>
@@ -7302,6 +7528,13 @@
             <a:prstDash val="solid"/>
           </a:ln>
         </p:spPr>
+        <p:txBody>
+          <a:bodyPr/>
+          <a:lstStyle/>
+          <a:p>
+            <a:endParaRPr lang="en-US"/>
+          </a:p>
+        </p:txBody>
       </p:sp>
       <p:sp>
         <p:nvSpPr>
@@ -7324,7 +7557,7 @@
           <a:bodyPr wrap="square" lIns="0" tIns="0" rIns="0" bIns="0" rtlCol="0" anchor="ctr"/>
           <a:lstStyle/>
           <a:p>
-            <a:pPr indent="0" marL="0">
+            <a:pPr marL="0" indent="0">
               <a:buNone/>
             </a:pPr>
             <a:r>
@@ -7366,6 +7599,13 @@
             <a:prstDash val="solid"/>
           </a:ln>
         </p:spPr>
+        <p:txBody>
+          <a:bodyPr/>
+          <a:lstStyle/>
+          <a:p>
+            <a:endParaRPr lang="en-US"/>
+          </a:p>
+        </p:txBody>
       </p:sp>
       <p:sp>
         <p:nvSpPr>
@@ -7388,7 +7628,7 @@
           <a:bodyPr wrap="square" lIns="0" tIns="0" rIns="0" bIns="0" rtlCol="0" anchor="t"/>
           <a:lstStyle/>
           <a:p>
-            <a:pPr indent="0" marL="0">
+            <a:pPr marL="0" indent="0">
               <a:buNone/>
             </a:pPr>
             <a:r>
@@ -7405,7 +7645,7 @@
             <a:endParaRPr lang="en-US" sz="1100" dirty="0"/>
           </a:p>
           <a:p>
-            <a:pPr indent="0" marL="0">
+            <a:pPr marL="0" indent="0">
               <a:buNone/>
             </a:pPr>
             <a:r>
@@ -7422,7 +7662,7 @@
             <a:endParaRPr lang="en-US" sz="1100" dirty="0"/>
           </a:p>
           <a:p>
-            <a:pPr indent="0" marL="0">
+            <a:pPr marL="0" indent="0">
               <a:buNone/>
             </a:pPr>
             <a:r>
@@ -7468,6 +7708,13 @@
             <a:prstDash val="solid"/>
           </a:ln>
         </p:spPr>
+        <p:txBody>
+          <a:bodyPr/>
+          <a:lstStyle/>
+          <a:p>
+            <a:endParaRPr lang="en-US"/>
+          </a:p>
+        </p:txBody>
       </p:sp>
       <p:sp>
         <p:nvSpPr>
@@ -7490,7 +7737,7 @@
           <a:bodyPr wrap="square" lIns="0" tIns="0" rIns="0" bIns="0" rtlCol="0" anchor="ctr"/>
           <a:lstStyle/>
           <a:p>
-            <a:pPr indent="0" marL="0">
+            <a:pPr marL="0" indent="0">
               <a:buNone/>
             </a:pPr>
             <a:r>
@@ -7524,6 +7771,7 @@
         <a:solidFill>
           <a:srgbClr val="FFFFFF"/>
         </a:solidFill>
+        <a:effectLst/>
       </p:bgPr>
     </p:bg>
     <p:spTree>
@@ -7542,14 +7790,14 @@
       </p:grpSpPr>
       <p:pic>
         <p:nvPicPr>
-          <p:cNvPr id="2" name="Image 0" descr="/Users/michael.liu/Documents/School/CS520/cs520-project/final_ppt/images/pacman_neon_bg.png">    </p:cNvPr>
+          <p:cNvPr id="2" name="Image 0" descr="/Users/michael.liu/Documents/School/CS520/cs520-project/final_ppt/images/pacman_neon_bg.png"/>
           <p:cNvPicPr>
             <a:picLocks noChangeAspect="1"/>
           </p:cNvPicPr>
           <p:nvPr/>
         </p:nvPicPr>
         <p:blipFill>
-          <a:blip r:embed="rId1"/>
+          <a:blip r:embed="rId3"/>
           <a:stretch>
             <a:fillRect/>
           </a:stretch>
@@ -7572,7 +7820,7 @@
         </p:nvSpPr>
         <p:spPr>
           <a:xfrm>
-            <a:off x="0" y="0"/>
+            <a:off x="0" y="57150"/>
             <a:ext cx="12191695" cy="6858000"/>
           </a:xfrm>
           <a:prstGeom prst="rect">
@@ -7592,6 +7840,13 @@
             <a:prstDash val="solid"/>
           </a:ln>
         </p:spPr>
+        <p:txBody>
+          <a:bodyPr/>
+          <a:lstStyle/>
+          <a:p>
+            <a:endParaRPr lang="en-US" dirty="0"/>
+          </a:p>
+        </p:txBody>
       </p:sp>
       <p:sp>
         <p:nvSpPr>
@@ -7601,7 +7856,7 @@
         </p:nvSpPr>
         <p:spPr>
           <a:xfrm>
-            <a:off x="640080" y="420624"/>
+            <a:off x="640080" y="203454"/>
             <a:ext cx="10927080" cy="640080"/>
           </a:xfrm>
           <a:prstGeom prst="rect">
@@ -7614,7 +7869,7 @@
           <a:bodyPr wrap="square" lIns="0" tIns="0" rIns="0" bIns="0" rtlCol="0" anchor="ctr"/>
           <a:lstStyle/>
           <a:p>
-            <a:pPr indent="0" marL="0">
+            <a:pPr marL="0" indent="0">
               <a:buNone/>
             </a:pPr>
             <a:r>
@@ -7640,7 +7895,7 @@
         </p:nvSpPr>
         <p:spPr>
           <a:xfrm>
-            <a:off x="640080" y="1097280"/>
+            <a:off x="640080" y="880110"/>
             <a:ext cx="10927080" cy="0"/>
           </a:xfrm>
           <a:prstGeom prst="line">
@@ -7656,6 +7911,13 @@
             <a:prstDash val="solid"/>
           </a:ln>
         </p:spPr>
+        <p:txBody>
+          <a:bodyPr/>
+          <a:lstStyle/>
+          <a:p>
+            <a:endParaRPr lang="en-US"/>
+          </a:p>
+        </p:txBody>
       </p:sp>
       <p:sp>
         <p:nvSpPr>
@@ -7665,7 +7927,7 @@
         </p:nvSpPr>
         <p:spPr>
           <a:xfrm>
-            <a:off x="640080" y="1243584"/>
+            <a:off x="640080" y="1026414"/>
             <a:ext cx="10927080" cy="548640"/>
           </a:xfrm>
           <a:prstGeom prst="roundRect">
@@ -7685,6 +7947,13 @@
             <a:prstDash val="solid"/>
           </a:ln>
         </p:spPr>
+        <p:txBody>
+          <a:bodyPr/>
+          <a:lstStyle/>
+          <a:p>
+            <a:endParaRPr lang="en-US"/>
+          </a:p>
+        </p:txBody>
       </p:sp>
       <p:sp>
         <p:nvSpPr>
@@ -7694,7 +7963,7 @@
         </p:nvSpPr>
         <p:spPr>
           <a:xfrm>
-            <a:off x="896112" y="1353312"/>
+            <a:off x="896112" y="1136142"/>
             <a:ext cx="10415016" cy="329184"/>
           </a:xfrm>
           <a:prstGeom prst="rect">
@@ -7707,7 +7976,7 @@
           <a:bodyPr wrap="square" lIns="0" tIns="0" rIns="0" bIns="0" rtlCol="0" anchor="ctr"/>
           <a:lstStyle/>
           <a:p>
-            <a:pPr indent="0" marL="0">
+            <a:pPr marL="0" indent="0">
               <a:buNone/>
             </a:pPr>
             <a:r>
@@ -7733,8 +8002,8 @@
         </p:nvSpPr>
         <p:spPr>
           <a:xfrm>
-            <a:off x="640080" y="1920240"/>
-            <a:ext cx="10927080" cy="1783080"/>
+            <a:off x="640080" y="1703070"/>
+            <a:ext cx="5440680" cy="1780634"/>
           </a:xfrm>
           <a:prstGeom prst="roundRect">
             <a:avLst>
@@ -7753,6 +8022,13 @@
             <a:prstDash val="solid"/>
           </a:ln>
         </p:spPr>
+        <p:txBody>
+          <a:bodyPr/>
+          <a:lstStyle/>
+          <a:p>
+            <a:endParaRPr lang="en-US"/>
+          </a:p>
+        </p:txBody>
       </p:sp>
       <p:sp>
         <p:nvSpPr>
@@ -7762,7 +8038,7 @@
         </p:nvSpPr>
         <p:spPr>
           <a:xfrm>
-            <a:off x="868680" y="2084832"/>
+            <a:off x="868680" y="1867662"/>
             <a:ext cx="10469880" cy="292608"/>
           </a:xfrm>
           <a:prstGeom prst="rect">
@@ -7775,7 +8051,7 @@
           <a:bodyPr wrap="square" lIns="0" tIns="0" rIns="0" bIns="0" rtlCol="0" anchor="ctr"/>
           <a:lstStyle/>
           <a:p>
-            <a:pPr indent="0" marL="0">
+            <a:pPr marL="0" indent="0">
               <a:buNone/>
             </a:pPr>
             <a:r>
@@ -7800,9 +8076,9 @@
           <p:nvPr/>
         </p:nvSpPr>
         <p:spPr>
-          <a:xfrm>
-            <a:off x="868680" y="2423160"/>
-            <a:ext cx="10469880" cy="0"/>
+          <a:xfrm flipV="1">
+            <a:off x="868680" y="2160270"/>
+            <a:ext cx="4983480" cy="45720"/>
           </a:xfrm>
           <a:prstGeom prst="line">
             <a:avLst/>
@@ -7817,6 +8093,13 @@
             <a:prstDash val="solid"/>
           </a:ln>
         </p:spPr>
+        <p:txBody>
+          <a:bodyPr/>
+          <a:lstStyle/>
+          <a:p>
+            <a:endParaRPr lang="en-US"/>
+          </a:p>
+        </p:txBody>
       </p:sp>
       <p:sp>
         <p:nvSpPr>
@@ -7826,7 +8109,7 @@
         </p:nvSpPr>
         <p:spPr>
           <a:xfrm>
-            <a:off x="868680" y="2560320"/>
+            <a:off x="868680" y="2343150"/>
             <a:ext cx="10469880" cy="1005840"/>
           </a:xfrm>
           <a:prstGeom prst="rect">
@@ -7839,7 +8122,7 @@
           <a:bodyPr wrap="square" lIns="0" tIns="0" rIns="0" bIns="0" rtlCol="0" anchor="t"/>
           <a:lstStyle/>
           <a:p>
-            <a:pPr indent="0" marL="0">
+            <a:pPr marL="0" indent="0">
               <a:buNone/>
             </a:pPr>
             <a:r>
@@ -7856,7 +8139,7 @@
             <a:endParaRPr lang="en-US" sz="1200" dirty="0"/>
           </a:p>
           <a:p>
-            <a:pPr indent="0" marL="0">
+            <a:pPr marL="0" indent="0">
               <a:buNone/>
             </a:pPr>
             <a:r>
@@ -7873,7 +8156,7 @@
             <a:endParaRPr lang="en-US" sz="1200" dirty="0"/>
           </a:p>
           <a:p>
-            <a:pPr indent="0" marL="0">
+            <a:pPr marL="0" indent="0">
               <a:buNone/>
             </a:pPr>
             <a:r>
@@ -7890,7 +8173,7 @@
             <a:endParaRPr lang="en-US" sz="1200" dirty="0"/>
           </a:p>
           <a:p>
-            <a:pPr indent="0" marL="0">
+            <a:pPr marL="0" indent="0">
               <a:buNone/>
             </a:pPr>
             <a:r>
@@ -7902,7 +8185,7 @@
                 <a:ea typeface="Arial" pitchFamily="34" charset="-122"/>
                 <a:cs typeface="Arial" pitchFamily="34" charset="-120"/>
               </a:rPr>
-              <a:t>• Two-stage MDP probe                              →   50-seed Monte Carlo on the maze</a:t>
+              <a:t>• Two-stage MDP probe                      →   50-seed Monte Carlo on the maze</a:t>
             </a:r>
             <a:endParaRPr lang="en-US" sz="1200" dirty="0"/>
           </a:p>
@@ -7916,8 +8199,8 @@
         </p:nvSpPr>
         <p:spPr>
           <a:xfrm>
-            <a:off x="640080" y="3794760"/>
-            <a:ext cx="5440680" cy="2148840"/>
+            <a:off x="6149340" y="1700625"/>
+            <a:ext cx="5440680" cy="1783080"/>
           </a:xfrm>
           <a:prstGeom prst="roundRect">
             <a:avLst>
@@ -7936,6 +8219,13 @@
             <a:prstDash val="solid"/>
           </a:ln>
         </p:spPr>
+        <p:txBody>
+          <a:bodyPr/>
+          <a:lstStyle/>
+          <a:p>
+            <a:endParaRPr lang="en-US"/>
+          </a:p>
+        </p:txBody>
       </p:sp>
       <p:sp>
         <p:nvSpPr>
@@ -7945,7 +8235,7 @@
         </p:nvSpPr>
         <p:spPr>
           <a:xfrm>
-            <a:off x="868680" y="3959352"/>
+            <a:off x="6327648" y="1812798"/>
             <a:ext cx="4983480" cy="292608"/>
           </a:xfrm>
           <a:prstGeom prst="rect">
@@ -7958,9 +8248,6 @@
           <a:bodyPr wrap="square" lIns="0" tIns="0" rIns="0" bIns="0" rtlCol="0" anchor="ctr"/>
           <a:lstStyle/>
           <a:p>
-            <a:pPr indent="0" marL="0">
-              <a:buNone/>
-            </a:pPr>
             <a:r>
               <a:rPr lang="en-US" sz="1400" b="1" dirty="0">
                 <a:solidFill>
@@ -7970,7 +8257,7 @@
                 <a:ea typeface="Arial" pitchFamily="34" charset="-122"/>
                 <a:cs typeface="Arial" pitchFamily="34" charset="-120"/>
               </a:rPr>
-              <a:t>Echo 1 — Both routes reach competent play</a:t>
+              <a:t>Echo 2 — Habits and planning live side by side</a:t>
             </a:r>
             <a:endParaRPr lang="en-US" sz="1400" dirty="0"/>
           </a:p>
@@ -7984,7 +8271,7 @@
         </p:nvSpPr>
         <p:spPr>
           <a:xfrm>
-            <a:off x="868680" y="4297680"/>
+            <a:off x="6224867" y="2160270"/>
             <a:ext cx="4983480" cy="0"/>
           </a:xfrm>
           <a:prstGeom prst="line">
@@ -8000,77 +8287,11 @@
             <a:prstDash val="solid"/>
           </a:ln>
         </p:spPr>
-      </p:sp>
-      <p:sp>
-        <p:nvSpPr>
-          <p:cNvPr id="15" name="Text 12"/>
-          <p:cNvSpPr/>
-          <p:nvPr/>
-        </p:nvSpPr>
-        <p:spPr>
-          <a:xfrm>
-            <a:off x="868680" y="4434840"/>
-            <a:ext cx="4983480" cy="1371600"/>
-          </a:xfrm>
-          <a:prstGeom prst="rect">
-            <a:avLst/>
-          </a:prstGeom>
-          <a:noFill/>
-          <a:ln/>
-        </p:spPr>
-        <p:txBody>
-          <a:bodyPr wrap="square" lIns="0" tIns="0" rIns="0" bIns="0" rtlCol="0" anchor="t"/>
-          <a:lstStyle/>
-          <a:p>
-            <a:pPr indent="0" marL="0">
-              <a:buNone/>
-            </a:pPr>
-            <a:r>
-              <a:rPr lang="en-US" sz="1150" dirty="0">
-                <a:solidFill>
-                  <a:srgbClr val="FFFFFF"/>
-                </a:solidFill>
-                <a:latin typeface="Arial" pitchFamily="34" charset="0"/>
-                <a:ea typeface="Arial" pitchFamily="34" charset="-122"/>
-                <a:cs typeface="Arial" pitchFamily="34" charset="-120"/>
-              </a:rPr>
-              <a:t>• Decker et al.: more model-based reasoning → more reward in two-stage MDPs.</a:t>
-            </a:r>
-            <a:endParaRPr lang="en-US" sz="1150" dirty="0"/>
-          </a:p>
-          <a:p>
-            <a:pPr indent="0" marL="0">
-              <a:buNone/>
-            </a:pPr>
-            <a:r>
-              <a:rPr lang="en-US" sz="1150" dirty="0">
-                <a:solidFill>
-                  <a:srgbClr val="FFFFFF"/>
-                </a:solidFill>
-                <a:latin typeface="Arial" pitchFamily="34" charset="0"/>
-                <a:ea typeface="Arial" pitchFamily="34" charset="-122"/>
-                <a:cs typeface="Arial" pitchFamily="34" charset="-120"/>
-              </a:rPr>
-              <a:t>• Our run: both families end up well above the heuristic — Q-learning 3,249–3,757, planners ≈ 3,150.</a:t>
-            </a:r>
-            <a:endParaRPr lang="en-US" sz="1150" dirty="0"/>
-          </a:p>
-          <a:p>
-            <a:pPr indent="0" marL="0">
-              <a:buNone/>
-            </a:pPr>
-            <a:r>
-              <a:rPr lang="en-US" sz="1150" dirty="0">
-                <a:solidFill>
-                  <a:srgbClr val="FFFFFF"/>
-                </a:solidFill>
-                <a:latin typeface="Arial" pitchFamily="34" charset="0"/>
-                <a:ea typeface="Arial" pitchFamily="34" charset="-122"/>
-                <a:cs typeface="Arial" pitchFamily="34" charset="-120"/>
-              </a:rPr>
-              <a:t>• Clear rate: model 3 24% &gt; model 2 20% &gt; model 1 16% &gt; planners 14% &gt; Static A* 6%.</a:t>
-            </a:r>
-            <a:endParaRPr lang="en-US" sz="1150" dirty="0"/>
+        <p:txBody>
+          <a:bodyPr/>
+          <a:lstStyle/>
+          <a:p>
+            <a:endParaRPr lang="en-US"/>
           </a:p>
         </p:txBody>
       </p:sp>
@@ -8082,8 +8303,8 @@
         </p:nvSpPr>
         <p:spPr>
           <a:xfrm>
-            <a:off x="6126480" y="3794760"/>
-            <a:ext cx="5440680" cy="2148840"/>
+            <a:off x="544202" y="3620864"/>
+            <a:ext cx="11045817" cy="3033681"/>
           </a:xfrm>
           <a:prstGeom prst="roundRect">
             <a:avLst>
@@ -8102,6 +8323,13 @@
             <a:prstDash val="solid"/>
           </a:ln>
         </p:spPr>
+        <p:txBody>
+          <a:bodyPr/>
+          <a:lstStyle/>
+          <a:p>
+            <a:endParaRPr lang="en-US"/>
+          </a:p>
+        </p:txBody>
       </p:sp>
       <p:sp>
         <p:nvSpPr>
@@ -8124,58 +8352,22 @@
           <a:bodyPr wrap="square" lIns="0" tIns="0" rIns="0" bIns="0" rtlCol="0" anchor="ctr"/>
           <a:lstStyle/>
           <a:p>
-            <a:pPr indent="0" marL="0">
-              <a:buNone/>
-            </a:pPr>
-            <a:r>
-              <a:rPr lang="en-US" sz="1400" b="1" dirty="0">
-                <a:solidFill>
-                  <a:srgbClr val="FFFFFF"/>
-                </a:solidFill>
-                <a:latin typeface="Arial" pitchFamily="34" charset="0"/>
-                <a:ea typeface="Arial" pitchFamily="34" charset="-122"/>
-                <a:cs typeface="Arial" pitchFamily="34" charset="-120"/>
-              </a:rPr>
-              <a:t>Echo 2 — Habits and planning live side by side</a:t>
-            </a:r>
+            <a:pPr marL="0" indent="0">
+              <a:buNone/>
+            </a:pPr>
             <a:endParaRPr lang="en-US" sz="1400" dirty="0"/>
           </a:p>
         </p:txBody>
       </p:sp>
       <p:sp>
         <p:nvSpPr>
-          <p:cNvPr id="18" name="Shape 15"/>
-          <p:cNvSpPr/>
-          <p:nvPr/>
-        </p:nvSpPr>
-        <p:spPr>
-          <a:xfrm>
-            <a:off x="6355080" y="4297680"/>
-            <a:ext cx="4983480" cy="0"/>
-          </a:xfrm>
-          <a:prstGeom prst="line">
-            <a:avLst/>
-          </a:prstGeom>
-          <a:noFill/>
-          <a:ln w="12700">
-            <a:solidFill>
-              <a:srgbClr val="1E88E5">
-                <a:alpha val="78000"/>
-              </a:srgbClr>
-            </a:solidFill>
-            <a:prstDash val="solid"/>
-          </a:ln>
-        </p:spPr>
-      </p:sp>
-      <p:sp>
-        <p:nvSpPr>
           <p:cNvPr id="19" name="Text 16"/>
           <p:cNvSpPr/>
           <p:nvPr/>
         </p:nvSpPr>
         <p:spPr>
           <a:xfrm>
-            <a:off x="6355080" y="4434840"/>
+            <a:off x="6309360" y="2242566"/>
             <a:ext cx="4983480" cy="1371600"/>
           </a:xfrm>
           <a:prstGeom prst="rect">
@@ -8188,7 +8380,7 @@
           <a:bodyPr wrap="square" lIns="0" tIns="0" rIns="0" bIns="0" rtlCol="0" anchor="t"/>
           <a:lstStyle/>
           <a:p>
-            <a:pPr indent="0" marL="0">
+            <a:pPr marL="0" indent="0">
               <a:buNone/>
             </a:pPr>
             <a:r>
@@ -8205,7 +8397,7 @@
             <a:endParaRPr lang="en-US" sz="1150" dirty="0"/>
           </a:p>
           <a:p>
-            <a:pPr indent="0" marL="0">
+            <a:pPr marL="0" indent="0">
               <a:buNone/>
             </a:pPr>
             <a:r>
@@ -8222,7 +8414,7 @@
             <a:endParaRPr lang="en-US" sz="1150" dirty="0"/>
           </a:p>
           <a:p>
-            <a:pPr indent="0" marL="0">
+            <a:pPr marL="0" indent="0">
               <a:buNone/>
             </a:pPr>
             <a:r>
@@ -8239,7 +8431,7 @@
             <a:endParaRPr lang="en-US" sz="1150" dirty="0"/>
           </a:p>
           <a:p>
-            <a:pPr indent="0" marL="0">
+            <a:pPr marL="0" indent="0">
               <a:buNone/>
             </a:pPr>
             <a:r>
@@ -8257,74 +8449,66 @@
           </a:p>
         </p:txBody>
       </p:sp>
-      <p:sp>
-        <p:nvSpPr>
-          <p:cNvPr id="20" name="Shape 17"/>
-          <p:cNvSpPr/>
-          <p:nvPr/>
-        </p:nvSpPr>
-        <p:spPr>
-          <a:xfrm>
-            <a:off x="640080" y="6345936"/>
-            <a:ext cx="10927080" cy="384048"/>
-          </a:xfrm>
-          <a:prstGeom prst="roundRect">
-            <a:avLst>
-              <a:gd name="adj" fmla="val 19048"/>
-            </a:avLst>
-          </a:prstGeom>
-          <a:solidFill>
-            <a:srgbClr val="1A2030">
-              <a:alpha val="80000"/>
-            </a:srgbClr>
-          </a:solidFill>
-          <a:ln w="12700">
-            <a:solidFill>
-              <a:srgbClr val="D9E2EC"/>
-            </a:solidFill>
-            <a:prstDash val="solid"/>
-          </a:ln>
-        </p:spPr>
-      </p:sp>
-      <p:sp>
-        <p:nvSpPr>
-          <p:cNvPr id="21" name="Text 18"/>
-          <p:cNvSpPr/>
-          <p:nvPr/>
-        </p:nvSpPr>
-        <p:spPr>
-          <a:xfrm>
-            <a:off x="896112" y="6455664"/>
-            <a:ext cx="10415016" cy="164592"/>
-          </a:xfrm>
-          <a:prstGeom prst="rect">
-            <a:avLst/>
-          </a:prstGeom>
-          <a:noFill/>
-          <a:ln/>
-        </p:spPr>
-        <p:txBody>
-          <a:bodyPr wrap="square" lIns="0" tIns="0" rIns="0" bIns="0" rtlCol="0" anchor="ctr"/>
-          <a:lstStyle/>
-          <a:p>
-            <a:pPr indent="0" marL="0">
-              <a:buNone/>
-            </a:pPr>
-            <a:r>
-              <a:rPr lang="en-US" sz="1100" dirty="0">
-                <a:solidFill>
-                  <a:srgbClr val="FFFFFF"/>
-                </a:solidFill>
-                <a:latin typeface="Arial" pitchFamily="34" charset="0"/>
-                <a:ea typeface="Arial" pitchFamily="34" charset="-122"/>
-                <a:cs typeface="Arial" pitchFamily="34" charset="-120"/>
-              </a:rPr>
-              <a:t>Risk-aware A* and Q-learning are complementary, not redundant. doi: 10.1177/0956797616639301.</a:t>
-            </a:r>
-            <a:endParaRPr lang="en-US" sz="1100" dirty="0"/>
-          </a:p>
-        </p:txBody>
-      </p:sp>
+      <p:pic>
+        <p:nvPicPr>
+          <p:cNvPr id="22" name="Picture 21">
+            <a:extLst>
+              <a:ext uri="{FF2B5EF4-FFF2-40B4-BE49-F238E27FC236}">
+                <a16:creationId xmlns:a16="http://schemas.microsoft.com/office/drawing/2014/main" id="{5962548E-CC38-C866-4B6C-1DDC9C2059DE}"/>
+              </a:ext>
+            </a:extLst>
+          </p:cNvPr>
+          <p:cNvPicPr>
+            <a:picLocks noChangeAspect="1"/>
+          </p:cNvPicPr>
+          <p:nvPr/>
+        </p:nvPicPr>
+        <p:blipFill>
+          <a:blip r:embed="rId4"/>
+          <a:stretch>
+            <a:fillRect/>
+          </a:stretch>
+        </p:blipFill>
+        <p:spPr>
+          <a:xfrm>
+            <a:off x="6508569" y="3348990"/>
+            <a:ext cx="4829991" cy="3243369"/>
+          </a:xfrm>
+          <a:prstGeom prst="rect">
+            <a:avLst/>
+          </a:prstGeom>
+        </p:spPr>
+      </p:pic>
+      <p:pic>
+        <p:nvPicPr>
+          <p:cNvPr id="23" name="Picture 22">
+            <a:extLst>
+              <a:ext uri="{FF2B5EF4-FFF2-40B4-BE49-F238E27FC236}">
+                <a16:creationId xmlns:a16="http://schemas.microsoft.com/office/drawing/2014/main" id="{2BBFF541-B9E7-49A5-2E40-789D70A2A03D}"/>
+              </a:ext>
+            </a:extLst>
+          </p:cNvPr>
+          <p:cNvPicPr>
+            <a:picLocks noChangeAspect="1"/>
+          </p:cNvPicPr>
+          <p:nvPr/>
+        </p:nvPicPr>
+        <p:blipFill>
+          <a:blip r:embed="rId5"/>
+          <a:stretch>
+            <a:fillRect/>
+          </a:stretch>
+        </p:blipFill>
+        <p:spPr>
+          <a:xfrm>
+            <a:off x="640079" y="3942284"/>
+            <a:ext cx="5868489" cy="2498666"/>
+          </a:xfrm>
+          <a:prstGeom prst="rect">
+            <a:avLst/>
+          </a:prstGeom>
+        </p:spPr>
+      </p:pic>
     </p:spTree>
   </p:cSld>
   <p:clrMapOvr>
@@ -8341,6 +8525,7 @@
         <a:solidFill>
           <a:srgbClr val="FFFFFF"/>
         </a:solidFill>
+        <a:effectLst/>
       </p:bgPr>
     </p:bg>
     <p:spTree>
@@ -8359,14 +8544,14 @@
       </p:grpSpPr>
       <p:pic>
         <p:nvPicPr>
-          <p:cNvPr id="2" name="Image 0" descr="/Users/michael.liu/Documents/School/CS520/cs520-project/final_ppt/images/pacman_neon_bg.png">    </p:cNvPr>
+          <p:cNvPr id="2" name="Image 0" descr="/Users/michael.liu/Documents/School/CS520/cs520-project/final_ppt/images/pacman_neon_bg.png"/>
           <p:cNvPicPr>
             <a:picLocks noChangeAspect="1"/>
           </p:cNvPicPr>
           <p:nvPr/>
         </p:nvPicPr>
         <p:blipFill>
-          <a:blip r:embed="rId1"/>
+          <a:blip r:embed="rId3"/>
           <a:stretch>
             <a:fillRect/>
           </a:stretch>
@@ -8409,6 +8594,13 @@
             <a:prstDash val="solid"/>
           </a:ln>
         </p:spPr>
+        <p:txBody>
+          <a:bodyPr/>
+          <a:lstStyle/>
+          <a:p>
+            <a:endParaRPr lang="en-US"/>
+          </a:p>
+        </p:txBody>
       </p:sp>
       <p:sp>
         <p:nvSpPr>
@@ -8431,7 +8623,7 @@
           <a:bodyPr wrap="square" lIns="0" tIns="0" rIns="0" bIns="0" rtlCol="0" anchor="ctr"/>
           <a:lstStyle/>
           <a:p>
-            <a:pPr indent="0" marL="0">
+            <a:pPr marL="0" indent="0">
               <a:buNone/>
             </a:pPr>
             <a:r>
@@ -8473,6 +8665,13 @@
             <a:prstDash val="solid"/>
           </a:ln>
         </p:spPr>
+        <p:txBody>
+          <a:bodyPr/>
+          <a:lstStyle/>
+          <a:p>
+            <a:endParaRPr lang="en-US"/>
+          </a:p>
+        </p:txBody>
       </p:sp>
       <p:sp>
         <p:nvSpPr>
@@ -8502,6 +8701,13 @@
             <a:prstDash val="solid"/>
           </a:ln>
         </p:spPr>
+        <p:txBody>
+          <a:bodyPr/>
+          <a:lstStyle/>
+          <a:p>
+            <a:endParaRPr lang="en-US"/>
+          </a:p>
+        </p:txBody>
       </p:sp>
       <p:sp>
         <p:nvSpPr>
@@ -8524,7 +8730,7 @@
           <a:bodyPr wrap="square" lIns="0" tIns="0" rIns="0" bIns="0" rtlCol="0" anchor="ctr"/>
           <a:lstStyle/>
           <a:p>
-            <a:pPr indent="0" marL="0">
+            <a:pPr marL="0" indent="0">
               <a:buNone/>
             </a:pPr>
             <a:r>
@@ -8570,6 +8776,13 @@
             <a:prstDash val="solid"/>
           </a:ln>
         </p:spPr>
+        <p:txBody>
+          <a:bodyPr/>
+          <a:lstStyle/>
+          <a:p>
+            <a:endParaRPr lang="en-US"/>
+          </a:p>
+        </p:txBody>
       </p:sp>
       <p:sp>
         <p:nvSpPr>
@@ -8592,7 +8805,7 @@
           <a:bodyPr wrap="square" lIns="0" tIns="0" rIns="0" bIns="0" rtlCol="0" anchor="ctr"/>
           <a:lstStyle/>
           <a:p>
-            <a:pPr indent="0" marL="0">
+            <a:pPr marL="0" indent="0">
               <a:buNone/>
             </a:pPr>
             <a:r>
@@ -8634,6 +8847,13 @@
             <a:prstDash val="solid"/>
           </a:ln>
         </p:spPr>
+        <p:txBody>
+          <a:bodyPr/>
+          <a:lstStyle/>
+          <a:p>
+            <a:endParaRPr lang="en-US"/>
+          </a:p>
+        </p:txBody>
       </p:sp>
       <p:sp>
         <p:nvSpPr>
@@ -8656,7 +8876,7 @@
           <a:bodyPr wrap="square" lIns="0" tIns="0" rIns="0" bIns="0" rtlCol="0" anchor="t"/>
           <a:lstStyle/>
           <a:p>
-            <a:pPr indent="0" marL="0">
+            <a:pPr marL="0" indent="0">
               <a:buNone/>
             </a:pPr>
             <a:r>
@@ -8673,7 +8893,7 @@
             <a:endParaRPr lang="en-US" sz="1150" dirty="0"/>
           </a:p>
           <a:p>
-            <a:pPr indent="0" marL="0">
+            <a:pPr marL="0" indent="0">
               <a:buNone/>
             </a:pPr>
             <a:r>
@@ -8719,6 +8939,13 @@
             <a:prstDash val="solid"/>
           </a:ln>
         </p:spPr>
+        <p:txBody>
+          <a:bodyPr/>
+          <a:lstStyle/>
+          <a:p>
+            <a:endParaRPr lang="en-US"/>
+          </a:p>
+        </p:txBody>
       </p:sp>
       <p:sp>
         <p:nvSpPr>
@@ -8741,7 +8968,7 @@
           <a:bodyPr wrap="square" lIns="0" tIns="0" rIns="0" bIns="0" rtlCol="0" anchor="ctr"/>
           <a:lstStyle/>
           <a:p>
-            <a:pPr indent="0" marL="0">
+            <a:pPr marL="0" indent="0">
               <a:buNone/>
             </a:pPr>
             <a:r>
@@ -8783,6 +9010,13 @@
             <a:prstDash val="solid"/>
           </a:ln>
         </p:spPr>
+        <p:txBody>
+          <a:bodyPr/>
+          <a:lstStyle/>
+          <a:p>
+            <a:endParaRPr lang="en-US"/>
+          </a:p>
+        </p:txBody>
       </p:sp>
       <p:sp>
         <p:nvSpPr>
@@ -8805,7 +9039,7 @@
           <a:bodyPr wrap="square" lIns="0" tIns="0" rIns="0" bIns="0" rtlCol="0" anchor="t"/>
           <a:lstStyle/>
           <a:p>
-            <a:pPr indent="0" marL="0">
+            <a:pPr marL="0" indent="0">
               <a:buNone/>
             </a:pPr>
             <a:r>
@@ -8822,7 +9056,7 @@
             <a:endParaRPr lang="en-US" sz="1150" dirty="0"/>
           </a:p>
           <a:p>
-            <a:pPr indent="0" marL="0">
+            <a:pPr marL="0" indent="0">
               <a:buNone/>
             </a:pPr>
             <a:r>
@@ -8868,6 +9102,13 @@
             <a:prstDash val="solid"/>
           </a:ln>
         </p:spPr>
+        <p:txBody>
+          <a:bodyPr/>
+          <a:lstStyle/>
+          <a:p>
+            <a:endParaRPr lang="en-US"/>
+          </a:p>
+        </p:txBody>
       </p:sp>
       <p:sp>
         <p:nvSpPr>
@@ -8890,7 +9131,7 @@
           <a:bodyPr wrap="square" lIns="0" tIns="0" rIns="0" bIns="0" rtlCol="0" anchor="ctr"/>
           <a:lstStyle/>
           <a:p>
-            <a:pPr indent="0" marL="0">
+            <a:pPr marL="0" indent="0">
               <a:buNone/>
             </a:pPr>
             <a:r>
@@ -8932,6 +9173,13 @@
             <a:prstDash val="solid"/>
           </a:ln>
         </p:spPr>
+        <p:txBody>
+          <a:bodyPr/>
+          <a:lstStyle/>
+          <a:p>
+            <a:endParaRPr lang="en-US"/>
+          </a:p>
+        </p:txBody>
       </p:sp>
       <p:sp>
         <p:nvSpPr>
@@ -8954,7 +9202,7 @@
           <a:bodyPr wrap="square" lIns="0" tIns="0" rIns="0" bIns="0" rtlCol="0" anchor="t"/>
           <a:lstStyle/>
           <a:p>
-            <a:pPr indent="0" marL="0">
+            <a:pPr marL="0" indent="0">
               <a:buNone/>
             </a:pPr>
             <a:r>
@@ -8971,7 +9219,7 @@
             <a:endParaRPr lang="en-US" sz="1150" dirty="0"/>
           </a:p>
           <a:p>
-            <a:pPr indent="0" marL="0">
+            <a:pPr marL="0" indent="0">
               <a:buNone/>
             </a:pPr>
             <a:r>
@@ -9017,6 +9265,13 @@
             <a:prstDash val="solid"/>
           </a:ln>
         </p:spPr>
+        <p:txBody>
+          <a:bodyPr/>
+          <a:lstStyle/>
+          <a:p>
+            <a:endParaRPr lang="en-US"/>
+          </a:p>
+        </p:txBody>
       </p:sp>
       <p:sp>
         <p:nvSpPr>
@@ -9039,7 +9294,7 @@
           <a:bodyPr wrap="square" lIns="0" tIns="0" rIns="0" bIns="0" rtlCol="0" anchor="ctr"/>
           <a:lstStyle/>
           <a:p>
-            <a:pPr indent="0" marL="0">
+            <a:pPr marL="0" indent="0">
               <a:buNone/>
             </a:pPr>
             <a:r>
@@ -9081,6 +9336,13 @@
             <a:prstDash val="solid"/>
           </a:ln>
         </p:spPr>
+        <p:txBody>
+          <a:bodyPr/>
+          <a:lstStyle/>
+          <a:p>
+            <a:endParaRPr lang="en-US"/>
+          </a:p>
+        </p:txBody>
       </p:sp>
       <p:sp>
         <p:nvSpPr>
@@ -9103,7 +9365,7 @@
           <a:bodyPr wrap="square" lIns="0" tIns="0" rIns="0" bIns="0" rtlCol="0" anchor="t"/>
           <a:lstStyle/>
           <a:p>
-            <a:pPr indent="0" marL="0">
+            <a:pPr marL="0" indent="0">
               <a:buNone/>
             </a:pPr>
             <a:r>
@@ -9120,7 +9382,7 @@
             <a:endParaRPr lang="en-US" sz="1150" dirty="0"/>
           </a:p>
           <a:p>
-            <a:pPr indent="0" marL="0">
+            <a:pPr marL="0" indent="0">
               <a:buNone/>
             </a:pPr>
             <a:r>
@@ -9166,6 +9428,13 @@
             <a:prstDash val="solid"/>
           </a:ln>
         </p:spPr>
+        <p:txBody>
+          <a:bodyPr/>
+          <a:lstStyle/>
+          <a:p>
+            <a:endParaRPr lang="en-US"/>
+          </a:p>
+        </p:txBody>
       </p:sp>
       <p:sp>
         <p:nvSpPr>
@@ -9188,7 +9457,7 @@
           <a:bodyPr wrap="square" lIns="0" tIns="0" rIns="0" bIns="0" rtlCol="0" anchor="ctr"/>
           <a:lstStyle/>
           <a:p>
-            <a:pPr indent="0" marL="0">
+            <a:pPr marL="0" indent="0">
               <a:buNone/>
             </a:pPr>
             <a:r>
@@ -9234,6 +9503,13 @@
             <a:prstDash val="solid"/>
           </a:ln>
         </p:spPr>
+        <p:txBody>
+          <a:bodyPr/>
+          <a:lstStyle/>
+          <a:p>
+            <a:endParaRPr lang="en-US"/>
+          </a:p>
+        </p:txBody>
       </p:sp>
       <p:sp>
         <p:nvSpPr>
@@ -9256,7 +9532,7 @@
           <a:bodyPr wrap="square" lIns="0" tIns="0" rIns="0" bIns="0" rtlCol="0" anchor="ctr"/>
           <a:lstStyle/>
           <a:p>
-            <a:pPr indent="0" marL="0">
+            <a:pPr marL="0" indent="0">
               <a:buNone/>
             </a:pPr>
             <a:r>
@@ -9575,4 +9851,319 @@
     </a:ext>
   </a:extLst>
 </a:theme>
+</file>
+
+<file path=ppt/theme/theme2.xml><?xml version="1.0" encoding="utf-8"?>
+<a:theme xmlns:a="http://schemas.openxmlformats.org/drawingml/2006/main" name="Office Theme">
+  <a:themeElements>
+    <a:clrScheme name="Office">
+      <a:dk1>
+        <a:sysClr val="windowText" lastClr="000000"/>
+      </a:dk1>
+      <a:lt1>
+        <a:sysClr val="window" lastClr="FFFFFF"/>
+      </a:lt1>
+      <a:dk2>
+        <a:srgbClr val="0E2841"/>
+      </a:dk2>
+      <a:lt2>
+        <a:srgbClr val="E8E8E8"/>
+      </a:lt2>
+      <a:accent1>
+        <a:srgbClr val="156082"/>
+      </a:accent1>
+      <a:accent2>
+        <a:srgbClr val="E97132"/>
+      </a:accent2>
+      <a:accent3>
+        <a:srgbClr val="196B24"/>
+      </a:accent3>
+      <a:accent4>
+        <a:srgbClr val="0F9ED5"/>
+      </a:accent4>
+      <a:accent5>
+        <a:srgbClr val="A02B93"/>
+      </a:accent5>
+      <a:accent6>
+        <a:srgbClr val="4EA72E"/>
+      </a:accent6>
+      <a:hlink>
+        <a:srgbClr val="467886"/>
+      </a:hlink>
+      <a:folHlink>
+        <a:srgbClr val="96607D"/>
+      </a:folHlink>
+    </a:clrScheme>
+    <a:fontScheme name="Office">
+      <a:majorFont>
+        <a:latin typeface="Aptos Display" panose="02110004020202020204"/>
+        <a:ea typeface=""/>
+        <a:cs typeface=""/>
+        <a:font script="Jpan" typeface="游ゴシック Light"/>
+        <a:font script="Hang" typeface="맑은 고딕"/>
+        <a:font script="Hans" typeface="等线 Light"/>
+        <a:font script="Hant" typeface="新細明體"/>
+        <a:font script="Arab" typeface="Times New Roman"/>
+        <a:font script="Hebr" typeface="Times New Roman"/>
+        <a:font script="Thai" typeface="Angsana New"/>
+        <a:font script="Ethi" typeface="Nyala"/>
+        <a:font script="Beng" typeface="Vrinda"/>
+        <a:font script="Gujr" typeface="Shruti"/>
+        <a:font script="Khmr" typeface="MoolBoran"/>
+        <a:font script="Knda" typeface="Tunga"/>
+        <a:font script="Guru" typeface="Raavi"/>
+        <a:font script="Cans" typeface="Euphemia"/>
+        <a:font script="Cher" typeface="Plantagenet Cherokee"/>
+        <a:font script="Yiii" typeface="Microsoft Yi Baiti"/>
+        <a:font script="Tibt" typeface="Microsoft Himalaya"/>
+        <a:font script="Thaa" typeface="MV Boli"/>
+        <a:font script="Deva" typeface="Mangal"/>
+        <a:font script="Telu" typeface="Gautami"/>
+        <a:font script="Taml" typeface="Latha"/>
+        <a:font script="Syrc" typeface="Estrangelo Edessa"/>
+        <a:font script="Orya" typeface="Kalinga"/>
+        <a:font script="Mlym" typeface="Kartika"/>
+        <a:font script="Laoo" typeface="DokChampa"/>
+        <a:font script="Sinh" typeface="Iskoola Pota"/>
+        <a:font script="Mong" typeface="Mongolian Baiti"/>
+        <a:font script="Viet" typeface="Times New Roman"/>
+        <a:font script="Uigh" typeface="Microsoft Uighur"/>
+        <a:font script="Geor" typeface="Sylfaen"/>
+        <a:font script="Armn" typeface="Arial"/>
+        <a:font script="Bugi" typeface="Leelawadee UI"/>
+        <a:font script="Bopo" typeface="Microsoft JhengHei"/>
+        <a:font script="Java" typeface="Javanese Text"/>
+        <a:font script="Lisu" typeface="Segoe UI"/>
+        <a:font script="Mymr" typeface="Myanmar Text"/>
+        <a:font script="Nkoo" typeface="Ebrima"/>
+        <a:font script="Olck" typeface="Nirmala UI"/>
+        <a:font script="Osma" typeface="Ebrima"/>
+        <a:font script="Phag" typeface="Phagspa"/>
+        <a:font script="Syrn" typeface="Estrangelo Edessa"/>
+        <a:font script="Syrj" typeface="Estrangelo Edessa"/>
+        <a:font script="Syre" typeface="Estrangelo Edessa"/>
+        <a:font script="Sora" typeface="Nirmala UI"/>
+        <a:font script="Tale" typeface="Microsoft Tai Le"/>
+        <a:font script="Talu" typeface="Microsoft New Tai Lue"/>
+        <a:font script="Tfng" typeface="Ebrima"/>
+      </a:majorFont>
+      <a:minorFont>
+        <a:latin typeface="Aptos" panose="02110004020202020204"/>
+        <a:ea typeface=""/>
+        <a:cs typeface=""/>
+        <a:font script="Jpan" typeface="游ゴシック"/>
+        <a:font script="Hang" typeface="맑은 고딕"/>
+        <a:font script="Hans" typeface="等线"/>
+        <a:font script="Hant" typeface="新細明體"/>
+        <a:font script="Arab" typeface="Arial"/>
+        <a:font script="Hebr" typeface="Arial"/>
+        <a:font script="Thai" typeface="Cordia New"/>
+        <a:font script="Ethi" typeface="Nyala"/>
+        <a:font script="Beng" typeface="Vrinda"/>
+        <a:font script="Gujr" typeface="Shruti"/>
+        <a:font script="Khmr" typeface="DaunPenh"/>
+        <a:font script="Knda" typeface="Tunga"/>
+        <a:font script="Guru" typeface="Raavi"/>
+        <a:font script="Cans" typeface="Euphemia"/>
+        <a:font script="Cher" typeface="Plantagenet Cherokee"/>
+        <a:font script="Yiii" typeface="Microsoft Yi Baiti"/>
+        <a:font script="Tibt" typeface="Microsoft Himalaya"/>
+        <a:font script="Thaa" typeface="MV Boli"/>
+        <a:font script="Deva" typeface="Mangal"/>
+        <a:font script="Telu" typeface="Gautami"/>
+        <a:font script="Taml" typeface="Latha"/>
+        <a:font script="Syrc" typeface="Estrangelo Edessa"/>
+        <a:font script="Orya" typeface="Kalinga"/>
+        <a:font script="Mlym" typeface="Kartika"/>
+        <a:font script="Laoo" typeface="DokChampa"/>
+        <a:font script="Sinh" typeface="Iskoola Pota"/>
+        <a:font script="Mong" typeface="Mongolian Baiti"/>
+        <a:font script="Viet" typeface="Arial"/>
+        <a:font script="Uigh" typeface="Microsoft Uighur"/>
+        <a:font script="Geor" typeface="Sylfaen"/>
+        <a:font script="Armn" typeface="Arial"/>
+        <a:font script="Bugi" typeface="Leelawadee UI"/>
+        <a:font script="Bopo" typeface="Microsoft JhengHei"/>
+        <a:font script="Java" typeface="Javanese Text"/>
+        <a:font script="Lisu" typeface="Segoe UI"/>
+        <a:font script="Mymr" typeface="Myanmar Text"/>
+        <a:font script="Nkoo" typeface="Ebrima"/>
+        <a:font script="Olck" typeface="Nirmala UI"/>
+        <a:font script="Osma" typeface="Ebrima"/>
+        <a:font script="Phag" typeface="Phagspa"/>
+        <a:font script="Syrn" typeface="Estrangelo Edessa"/>
+        <a:font script="Syrj" typeface="Estrangelo Edessa"/>
+        <a:font script="Syre" typeface="Estrangelo Edessa"/>
+        <a:font script="Sora" typeface="Nirmala UI"/>
+        <a:font script="Tale" typeface="Microsoft Tai Le"/>
+        <a:font script="Talu" typeface="Microsoft New Tai Lue"/>
+        <a:font script="Tfng" typeface="Ebrima"/>
+      </a:minorFont>
+    </a:fontScheme>
+    <a:fmtScheme name="Office">
+      <a:fillStyleLst>
+        <a:solidFill>
+          <a:schemeClr val="phClr"/>
+        </a:solidFill>
+        <a:gradFill rotWithShape="1">
+          <a:gsLst>
+            <a:gs pos="0">
+              <a:schemeClr val="phClr">
+                <a:lumMod val="110000"/>
+                <a:satMod val="105000"/>
+                <a:tint val="67000"/>
+              </a:schemeClr>
+            </a:gs>
+            <a:gs pos="50000">
+              <a:schemeClr val="phClr">
+                <a:lumMod val="105000"/>
+                <a:satMod val="103000"/>
+                <a:tint val="73000"/>
+              </a:schemeClr>
+            </a:gs>
+            <a:gs pos="100000">
+              <a:schemeClr val="phClr">
+                <a:lumMod val="105000"/>
+                <a:satMod val="109000"/>
+                <a:tint val="81000"/>
+              </a:schemeClr>
+            </a:gs>
+          </a:gsLst>
+          <a:lin ang="5400000" scaled="0"/>
+        </a:gradFill>
+        <a:gradFill rotWithShape="1">
+          <a:gsLst>
+            <a:gs pos="0">
+              <a:schemeClr val="phClr">
+                <a:satMod val="103000"/>
+                <a:lumMod val="102000"/>
+                <a:tint val="94000"/>
+              </a:schemeClr>
+            </a:gs>
+            <a:gs pos="50000">
+              <a:schemeClr val="phClr">
+                <a:satMod val="110000"/>
+                <a:lumMod val="100000"/>
+                <a:shade val="100000"/>
+              </a:schemeClr>
+            </a:gs>
+            <a:gs pos="100000">
+              <a:schemeClr val="phClr">
+                <a:lumMod val="99000"/>
+                <a:satMod val="120000"/>
+                <a:shade val="78000"/>
+              </a:schemeClr>
+            </a:gs>
+          </a:gsLst>
+          <a:lin ang="5400000" scaled="0"/>
+        </a:gradFill>
+      </a:fillStyleLst>
+      <a:lnStyleLst>
+        <a:ln w="12700" cap="flat" cmpd="sng" algn="ctr">
+          <a:solidFill>
+            <a:schemeClr val="phClr"/>
+          </a:solidFill>
+          <a:prstDash val="solid"/>
+          <a:miter lim="800000"/>
+        </a:ln>
+        <a:ln w="19050" cap="flat" cmpd="sng" algn="ctr">
+          <a:solidFill>
+            <a:schemeClr val="phClr"/>
+          </a:solidFill>
+          <a:prstDash val="solid"/>
+          <a:miter lim="800000"/>
+        </a:ln>
+        <a:ln w="25400" cap="flat" cmpd="sng" algn="ctr">
+          <a:solidFill>
+            <a:schemeClr val="phClr"/>
+          </a:solidFill>
+          <a:prstDash val="solid"/>
+          <a:miter lim="800000"/>
+        </a:ln>
+      </a:lnStyleLst>
+      <a:effectStyleLst>
+        <a:effectStyle>
+          <a:effectLst/>
+        </a:effectStyle>
+        <a:effectStyle>
+          <a:effectLst/>
+        </a:effectStyle>
+        <a:effectStyle>
+          <a:effectLst>
+            <a:outerShdw blurRad="57150" dist="19050" dir="5400000" algn="ctr" rotWithShape="0">
+              <a:srgbClr val="000000">
+                <a:alpha val="63000"/>
+              </a:srgbClr>
+            </a:outerShdw>
+          </a:effectLst>
+        </a:effectStyle>
+      </a:effectStyleLst>
+      <a:bgFillStyleLst>
+        <a:solidFill>
+          <a:schemeClr val="phClr"/>
+        </a:solidFill>
+        <a:solidFill>
+          <a:schemeClr val="phClr">
+            <a:tint val="95000"/>
+            <a:satMod val="170000"/>
+          </a:schemeClr>
+        </a:solidFill>
+        <a:gradFill rotWithShape="1">
+          <a:gsLst>
+            <a:gs pos="0">
+              <a:schemeClr val="phClr">
+                <a:tint val="93000"/>
+                <a:satMod val="150000"/>
+                <a:shade val="98000"/>
+                <a:lumMod val="102000"/>
+              </a:schemeClr>
+            </a:gs>
+            <a:gs pos="50000">
+              <a:schemeClr val="phClr">
+                <a:tint val="98000"/>
+                <a:satMod val="130000"/>
+                <a:shade val="90000"/>
+                <a:lumMod val="103000"/>
+              </a:schemeClr>
+            </a:gs>
+            <a:gs pos="100000">
+              <a:schemeClr val="phClr">
+                <a:shade val="63000"/>
+                <a:satMod val="120000"/>
+              </a:schemeClr>
+            </a:gs>
+          </a:gsLst>
+          <a:lin ang="5400000" scaled="0"/>
+        </a:gradFill>
+      </a:bgFillStyleLst>
+    </a:fmtScheme>
+  </a:themeElements>
+  <a:objectDefaults>
+    <a:lnDef>
+      <a:spPr/>
+      <a:bodyPr/>
+      <a:lstStyle/>
+      <a:style>
+        <a:lnRef idx="2">
+          <a:schemeClr val="accent1"/>
+        </a:lnRef>
+        <a:fillRef idx="0">
+          <a:schemeClr val="accent1"/>
+        </a:fillRef>
+        <a:effectRef idx="1">
+          <a:schemeClr val="accent1"/>
+        </a:effectRef>
+        <a:fontRef idx="minor">
+          <a:schemeClr val="tx1"/>
+        </a:fontRef>
+      </a:style>
+    </a:lnDef>
+  </a:objectDefaults>
+  <a:extraClrSchemeLst/>
+  <a:extLst>
+    <a:ext uri="{05A4C25C-085E-4340-85A3-A5531E510DB2}">
+      <thm15:themeFamily xmlns:thm15="http://schemas.microsoft.com/office/thememl/2012/main" name="Office Theme" id="{2E142A2C-CD16-42D6-873A-C26D2A0506FA}" vid="{1BDDFF52-6CD6-40A5-AB3C-68EB2F1E4D0A}"/>
+    </a:ext>
+  </a:extLst>
+</a:theme>
 </file>
</xml_diff>

<commit_message>
Shorten Final Report and add doc
</commit_message>
<xml_diff>
--- a/final_ppt/pacman_rl_final.pptx
+++ b/final_ppt/pacman_rl_final.pptx
@@ -8734,17 +8734,6 @@
               <a:buNone/>
             </a:pPr>
             <a:r>
-              <a:rPr lang="en-US" sz="1400" b="1">
-                <a:solidFill>
-                  <a:srgbClr val="FFFFFF"/>
-                </a:solidFill>
-                <a:latin typeface="Arial" pitchFamily="34" charset="0"/>
-                <a:ea typeface="Arial" pitchFamily="34" charset="-122"/>
-                <a:cs typeface="Arial" pitchFamily="34" charset="-120"/>
-              </a:rPr>
-              <a:t>8 </a:t>
-            </a:r>
-            <a:r>
               <a:rPr lang="en-US" sz="1400" b="1" dirty="0">
                 <a:solidFill>
                   <a:srgbClr val="FFFFFF"/>
@@ -8753,7 +8742,7 @@
                 <a:ea typeface="Arial" pitchFamily="34" charset="-122"/>
                 <a:cs typeface="Arial" pitchFamily="34" charset="-120"/>
               </a:rPr>
-              <a:t>agents · 50 paired seeds · 28×36 Pac-Man — what we learned.</a:t>
+              <a:t>6 agents · 50 paired seeds · 28×36 Pac-Man — what we learned.</a:t>
             </a:r>
             <a:endParaRPr lang="en-US" sz="1400" dirty="0"/>
           </a:p>

</xml_diff>